<commit_message>
Credit figures to Alammar & Grootendorst, Hands-On Large Language Models (O'Reilly 2024) on every figure slide
Co-Authored-By: Claude Fable 5.1 <noreply@anthropic.com>
</commit_message>
<xml_diff>
--- a/instructor/ai-administrator/out/day1/Day1_S1_Foundations.pptx
+++ b/instructor/ai-administrator/out/day1/Day1_S1_Foundations.pptx
@@ -4843,7 +4843,7 @@
           <a:lstStyle/>
           <a:p>
             <a:r>
-              <a:t>Leave on screen during questions. All figures in this deck are from Maarten Grootendorst's 'A Visual Guide to LLM Agents', reused with credit as on the course website.</a:t>
+              <a:t>Leave on screen during questions. All figures in this deck are from Alammar and Grootendorst, Hands-On Large Language Models (O'Reilly, 2024), credited on each slide; the same figures appear in Grootendorst's online Visual Guide.</a:t>
             </a:r>
           </a:p>
         </p:txBody>
@@ -8666,7 +8666,7 @@
                 </a:solidFill>
                 <a:latin typeface="Calibri"/>
               </a:rPr>
-              <a:t>Figure: M. Grootendorst, A Visual Guide to LLM Agents</a:t>
+              <a:t>Figure: Alammar, J. and Grootendorst, M. (2024). Hands-On Large Language Models. O'Reilly Media</a:t>
             </a:r>
           </a:p>
         </p:txBody>
@@ -11024,7 +11024,7 @@
                 </a:solidFill>
                 <a:latin typeface="Calibri"/>
               </a:rPr>
-              <a:t>Figure: M. Grootendorst, A Visual Guide to LLM Agents</a:t>
+              <a:t>Figure: Alammar, J. and Grootendorst, M. (2024). Hands-On Large Language Models. O'Reilly Media</a:t>
             </a:r>
           </a:p>
         </p:txBody>
@@ -11373,7 +11373,7 @@
                 </a:solidFill>
                 <a:latin typeface="Calibri"/>
               </a:rPr>
-              <a:t>Figure: M. Grootendorst, A Visual Guide to LLM Agents</a:t>
+              <a:t>Figure: Alammar, J. and Grootendorst, M. (2024). Hands-On Large Language Models. O'Reilly Media</a:t>
             </a:r>
           </a:p>
         </p:txBody>
@@ -12064,7 +12064,7 @@
                 </a:solidFill>
                 <a:latin typeface="Calibri"/>
               </a:rPr>
-              <a:t>Figure: M. Grootendorst, A Visual Guide to LLM Agents</a:t>
+              <a:t>Figure: Alammar, J. and Grootendorst, M. (2024). Hands-On Large Language Models. O'Reilly Media</a:t>
             </a:r>
           </a:p>
         </p:txBody>
@@ -13437,7 +13437,7 @@
                 </a:solidFill>
                 <a:latin typeface="Calibri"/>
               </a:rPr>
-              <a:t>Figure: M. Grootendorst, A Visual Guide to LLM Agents</a:t>
+              <a:t>Figure: Alammar, J. and Grootendorst, M. (2024). Hands-On Large Language Models. O'Reilly Media</a:t>
             </a:r>
           </a:p>
         </p:txBody>
@@ -13786,7 +13786,7 @@
                 </a:solidFill>
                 <a:latin typeface="Calibri"/>
               </a:rPr>
-              <a:t>Figure: M. Grootendorst, A Visual Guide to LLM Agents</a:t>
+              <a:t>Figure: Alammar, J. and Grootendorst, M. (2024). Hands-On Large Language Models. O'Reilly Media</a:t>
             </a:r>
           </a:p>
         </p:txBody>
@@ -14222,7 +14222,7 @@
                 </a:solidFill>
                 <a:latin typeface="Calibri"/>
               </a:rPr>
-              <a:t>Figure: M. Grootendorst, A Visual Guide to LLM Agents</a:t>
+              <a:t>Figure: Alammar, J. and Grootendorst, M. (2024). Hands-On Large Language Models. O'Reilly Media</a:t>
             </a:r>
           </a:p>
         </p:txBody>
@@ -14642,7 +14642,7 @@
                 </a:solidFill>
                 <a:latin typeface="Calibri"/>
               </a:rPr>
-              <a:t>Figure: M. Grootendorst, A Visual Guide to LLM Agents</a:t>
+              <a:t>Figure: Alammar, J. and Grootendorst, M. (2024). Hands-On Large Language Models. O'Reilly Media</a:t>
             </a:r>
           </a:p>
         </p:txBody>
@@ -14991,7 +14991,7 @@
                 </a:solidFill>
                 <a:latin typeface="Calibri"/>
               </a:rPr>
-              <a:t>Figure: M. Grootendorst, A Visual Guide to LLM Agents</a:t>
+              <a:t>Figure: Alammar, J. and Grootendorst, M. (2024). Hands-On Large Language Models. O'Reilly Media</a:t>
             </a:r>
           </a:p>
         </p:txBody>
@@ -15340,7 +15340,7 @@
                 </a:solidFill>
                 <a:latin typeface="Calibri"/>
               </a:rPr>
-              <a:t>Figure: M. Grootendorst, A Visual Guide to LLM Agents</a:t>
+              <a:t>Figure: Alammar, J. and Grootendorst, M. (2024). Hands-On Large Language Models. O'Reilly Media</a:t>
             </a:r>
           </a:p>
         </p:txBody>
@@ -15689,7 +15689,7 @@
                 </a:solidFill>
                 <a:latin typeface="Calibri"/>
               </a:rPr>
-              <a:t>Figure: M. Grootendorst, A Visual Guide to LLM Agents</a:t>
+              <a:t>Figure: Alammar, J. and Grootendorst, M. (2024). Hands-On Large Language Models. O'Reilly Media</a:t>
             </a:r>
           </a:p>
         </p:txBody>
@@ -16038,7 +16038,7 @@
                 </a:solidFill>
                 <a:latin typeface="Calibri"/>
               </a:rPr>
-              <a:t>Figure: M. Grootendorst, A Visual Guide to LLM Agents</a:t>
+              <a:t>Figure: Alammar, J. and Grootendorst, M. (2024). Hands-On Large Language Models. O'Reilly Media</a:t>
             </a:r>
           </a:p>
         </p:txBody>
@@ -16435,7 +16435,7 @@
                 </a:solidFill>
                 <a:latin typeface="Calibri"/>
               </a:rPr>
-              <a:t>Figure: M. Grootendorst, A Visual Guide to LLM Agents</a:t>
+              <a:t>Figure: Alammar, J. and Grootendorst, M. (2024). Hands-On Large Language Models. O'Reilly Media</a:t>
             </a:r>
           </a:p>
         </p:txBody>
@@ -17142,7 +17142,7 @@
                 </a:solidFill>
                 <a:latin typeface="Calibri"/>
               </a:rPr>
-              <a:t>Figure: M. Grootendorst, A Visual Guide to LLM Agents</a:t>
+              <a:t>Figure: Alammar, J. and Grootendorst, M. (2024). Hands-On Large Language Models. O'Reilly Media</a:t>
             </a:r>
           </a:p>
         </p:txBody>
@@ -17491,7 +17491,7 @@
                 </a:solidFill>
                 <a:latin typeface="Calibri"/>
               </a:rPr>
-              <a:t>Figure: M. Grootendorst, A Visual Guide to LLM Agents</a:t>
+              <a:t>Figure: Alammar, J. and Grootendorst, M. (2024). Hands-On Large Language Models. O'Reilly Media</a:t>
             </a:r>
           </a:p>
         </p:txBody>
@@ -17840,7 +17840,7 @@
                 </a:solidFill>
                 <a:latin typeface="Calibri"/>
               </a:rPr>
-              <a:t>Figure: M. Grootendorst, A Visual Guide to LLM Agents</a:t>
+              <a:t>Figure: Alammar, J. and Grootendorst, M. (2024). Hands-On Large Language Models. O'Reilly Media</a:t>
             </a:r>
           </a:p>
         </p:txBody>
@@ -18189,7 +18189,7 @@
                 </a:solidFill>
                 <a:latin typeface="Calibri"/>
               </a:rPr>
-              <a:t>Figure: M. Grootendorst, A Visual Guide to LLM Agents</a:t>
+              <a:t>Figure: Alammar, J. and Grootendorst, M. (2024). Hands-On Large Language Models. O'Reilly Media</a:t>
             </a:r>
           </a:p>
         </p:txBody>
@@ -20433,7 +20433,7 @@
                 </a:solidFill>
                 <a:latin typeface="Calibri"/>
               </a:rPr>
-              <a:t>Figure: M. Grootendorst, A Visual Guide to LLM Agents</a:t>
+              <a:t>Figure: Alammar, J. and Grootendorst, M. (2024). Hands-On Large Language Models. O'Reilly Media</a:t>
             </a:r>
           </a:p>
         </p:txBody>
@@ -20782,7 +20782,7 @@
                 </a:solidFill>
                 <a:latin typeface="Calibri"/>
               </a:rPr>
-              <a:t>Figure: M. Grootendorst, A Visual Guide to LLM Agents</a:t>
+              <a:t>Figure: Alammar, J. and Grootendorst, M. (2024). Hands-On Large Language Models. O'Reilly Media</a:t>
             </a:r>
           </a:p>
         </p:txBody>
@@ -22083,7 +22083,7 @@
                 </a:solidFill>
                 <a:latin typeface="Calibri"/>
               </a:rPr>
-              <a:t>Figure: M. Grootendorst, A Visual Guide to LLM Agents</a:t>
+              <a:t>Figure: Alammar, J. and Grootendorst, M. (2024). Hands-On Large Language Models. O'Reilly Media</a:t>
             </a:r>
           </a:p>
         </p:txBody>
@@ -24669,7 +24669,7 @@
                 </a:solidFill>
                 <a:latin typeface="Calibri"/>
               </a:rPr>
-              <a:t>Figure: M. Grootendorst, A Visual Guide to LLM Agents</a:t>
+              <a:t>Figure: Alammar, J. and Grootendorst, M. (2024). Hands-On Large Language Models. O'Reilly Media</a:t>
             </a:r>
           </a:p>
         </p:txBody>
@@ -25018,7 +25018,7 @@
                 </a:solidFill>
                 <a:latin typeface="Calibri"/>
               </a:rPr>
-              <a:t>Figure: M. Grootendorst, A Visual Guide to LLM Agents</a:t>
+              <a:t>Figure: Alammar, J. and Grootendorst, M. (2024). Hands-On Large Language Models. O'Reilly Media</a:t>
             </a:r>
           </a:p>
         </p:txBody>
@@ -25770,7 +25770,7 @@
                 </a:solidFill>
                 <a:latin typeface="Calibri"/>
               </a:rPr>
-              <a:t>Figure: M. Grootendorst, A Visual Guide to LLM Agents</a:t>
+              <a:t>Figure: Alammar, J. and Grootendorst, M. (2024). Hands-On Large Language Models. O'Reilly Media</a:t>
             </a:r>
           </a:p>
         </p:txBody>
@@ -38230,7 +38230,7 @@
                 </a:solidFill>
                 <a:latin typeface="Calibri"/>
               </a:rPr>
-              <a:t>Figure: M. Grootendorst, A Visual Guide to LLM Agents</a:t>
+              <a:t>Figure: Alammar, J. and Grootendorst, M. (2024). Hands-On Large Language Models. O'Reilly Media</a:t>
             </a:r>
           </a:p>
         </p:txBody>
@@ -38666,7 +38666,7 @@
                 </a:solidFill>
                 <a:latin typeface="Calibri"/>
               </a:rPr>
-              <a:t>Figure: M. Grootendorst, A Visual Guide to LLM Agents</a:t>
+              <a:t>Figure: Alammar, J. and Grootendorst, M. (2024). Hands-On Large Language Models. O'Reilly Media</a:t>
             </a:r>
           </a:p>
         </p:txBody>
@@ -39815,7 +39815,7 @@
                 </a:solidFill>
                 <a:latin typeface="Calibri"/>
               </a:rPr>
-              <a:t>4.  Grootendorst, M. (2025). A Visual Guide to LLM Agents. newsletter.maartengrootendorst.com (source of the diagrams in this deck)</a:t>
+              <a:t>4.  Grootendorst, M. (2025). A Visual Guide to LLM Agents. newsletter.maartengrootendorst.com (online version of the same diagrams)</a:t>
             </a:r>
           </a:p>
           <a:p>
@@ -40260,7 +40260,7 @@
                 </a:solidFill>
                 <a:latin typeface="Calibri"/>
               </a:rPr>
-              <a:t>Figure: M. Grootendorst, A Visual Guide to LLM Agents</a:t>
+              <a:t>Figure: Alammar, J. and Grootendorst, M. (2024). Hands-On Large Language Models. O'Reilly Media</a:t>
             </a:r>
           </a:p>
         </p:txBody>
@@ -40680,7 +40680,7 @@
                 </a:solidFill>
                 <a:latin typeface="Calibri"/>
               </a:rPr>
-              <a:t>Figure: M. Grootendorst, A Visual Guide to LLM Agents</a:t>
+              <a:t>Figure: Alammar, J. and Grootendorst, M. (2024). Hands-On Large Language Models. O'Reilly Media</a:t>
             </a:r>
           </a:p>
         </p:txBody>

</xml_diff>

<commit_message>
Add Session 1 Kahoot (30 balanced questions) and course-long server wording
</commit_message>
<xml_diff>
--- a/instructor/ai-administrator/out/day1/Day1_S1_Foundations.pptx
+++ b/instructor/ai-administrator/out/day1/Day1_S1_Foundations.pptx
@@ -25735,7 +25735,7 @@
                 </a:solidFill>
                 <a:latin typeface="Calibri"/>
               </a:rPr>
-              <a:t>•  Today's one lives on the instructor's laptop and is deleted after the session</a:t>
+              <a:t>•  Today's one runs on a small cloud server the instructor controls; what you tell it is deleted after the session</a:t>
             </a:r>
           </a:p>
         </p:txBody>
@@ -26670,7 +26670,7 @@
                 </a:solidFill>
                 <a:latin typeface="Calibri"/>
               </a:rPr>
-              <a:t>•  The bot and its memory are deleted after the session</a:t>
+              <a:t>•  What you tell it is deleted after the session</a:t>
             </a:r>
           </a:p>
         </p:txBody>
@@ -28470,7 +28470,7 @@
                 </a:solidFill>
                 <a:latin typeface="Calibri"/>
               </a:rPr>
-              <a:t>It runs on the instructor's laptop with the instructor's keys and permissions, has one tool, and is deleted after the session. Who holds the keys, which tools it may use, who can message it and who reads the log are the questions of Day 5 and Day 6.</a:t>
+              <a:t>It runs on a small cloud server with the instructor's keys and permissions, has one tool, and forgets you after the session. Who holds the keys, which tools it may use, who can message it and who reads the log are the questions of Day 5 and Day 6.</a:t>
             </a:r>
           </a:p>
         </p:txBody>

</xml_diff>

<commit_message>
Day 1: live Hermes bot QR, Kahoot before lab with logo, practical video (MP4 + GIF), deployment record
</commit_message>
<xml_diff>
--- a/instructor/ai-administrator/out/day1/Day1_S1_Foundations.pptx
+++ b/instructor/ai-administrator/out/day1/Day1_S1_Foundations.pptx
@@ -2104,7 +2104,7 @@
           <a:lstStyle/>
           <a:p>
             <a:r>
-              <a:t>Read the objectives quickly. The last one is the lab deliverable: a one-page task inventory. Everything else in the course builds on that inventory, so it matters more than the quiz.</a:t>
+              <a:t>Read the objectives quickly. Mention the Kahoot so phones are ready and attention holds to the end. The last one is the lab deliverable: a one-page task inventory. Everything else in the course builds on that inventory, so it matters more than the quiz.</a:t>
             </a:r>
           </a:p>
         </p:txBody>
@@ -3574,7 +3574,7 @@
           <a:lstStyle/>
           <a:p>
             <a:r>
-              <a:t>Share the handout and the spreadsheet template in the chat. Walk through the five steps in eight minutes; the inventory itself is homework. The common mistake is tasks that are too vague. Step 4 is where participants get their first taste of using an assistant as a colleague.</a:t>
+              <a:t>Import Day1_S1_Kahoot.xlsx into Kahoot beforehand (Create, then Import spreadsheet). Launch in Classic mode, show the PIN on this slide. Ten minutes covers roughly 15 to 20 questions with brief comments; assign the remainder as a challenge with a one-week deadline. The answer key with rationales is Day1_S1_Kahoot_Answer_Key.pdf. Say out loud that answer lengths are balanced, so participants stop guessing by length.</a:t>
             </a:r>
           </a:p>
         </p:txBody>
@@ -3714,7 +3714,7 @@
           <a:lstStyle/>
           <a:p>
             <a:r>
-              <a:t>Read it aloud and point at the parts: a role, a description of the input, a task, an output order, a constraint ('be brief'). Say: 'Tomorrow in Session 2 you will learn why this prompt is shaped like this.'</a:t>
+              <a:t>Share the handout and the spreadsheet template in the chat. Walk through the five steps in eight minutes; the inventory itself is homework. The common mistake is tasks that are too vague. Step 4 is where participants get their first taste of using an assistant as a colleague.</a:t>
             </a:r>
           </a:p>
         </p:txBody>
@@ -3784,7 +3784,7 @@
           <a:lstStyle/>
           <a:p>
             <a:r>
-              <a:t>Be explicit that this document is reused on Days 2, 3 and 5. Participants who skip it will have nothing to map tomorrow.</a:t>
+              <a:t>Read it aloud and point at the parts: a role, a description of the input, a task, an output order, a constraint ('be brief'). Say: 'Tomorrow in Session 2 you will learn why this prompt is shaped like this.'</a:t>
             </a:r>
           </a:p>
         </p:txBody>
@@ -3854,7 +3854,7 @@
           <a:lstStyle/>
           <a:p>
             <a:r>
-              <a:t>Import Day1_S1_Kahoot.xlsx into Kahoot beforehand (Create, then Import spreadsheet). Launch in Classic mode, show the PIN on this slide. Ten minutes covers roughly 15 to 20 questions with brief comments; assign the remainder as a challenge with a one-week deadline. The answer key with rationales is Day1_S1_Kahoot_Answer_Key.pdf. Say out loud that answer lengths are balanced, so participants stop guessing by length.</a:t>
+              <a:t>Be explicit that this document is reused on Days 2, 3 and 5. Participants who skip it will have nothing to map tomorrow.</a:t>
             </a:r>
           </a:p>
         </p:txBody>
@@ -12136,6 +12136,22 @@
               <a:t>•  Day 5 and 6: multi-agent, controls, security, monitoring · Day 7 and 8: capstone and exam</a:t>
             </a:r>
           </a:p>
+          <a:p>
+            <a:pPr>
+              <a:spcAft>
+                <a:spcPts val="1200"/>
+              </a:spcAft>
+            </a:pPr>
+            <a:r>
+              <a:rPr sz="2200">
+                <a:solidFill>
+                  <a:srgbClr val="111111"/>
+                </a:solidFill>
+                <a:latin typeface="Calibri"/>
+              </a:rPr>
+              <a:t>•  At minute 105 today: a Kahoot with 30 questions on this session. Keep your phone handy.</a:t>
+            </a:r>
+          </a:p>
         </p:txBody>
       </p:sp>
       <p:sp>
@@ -16155,6 +16171,22 @@
                 <a:latin typeface="Calibri"/>
               </a:rPr>
               <a:t>•  List three tasks from your own job that suit automation, and one that should stay with a person</a:t>
+            </a:r>
+          </a:p>
+          <a:p>
+            <a:pPr>
+              <a:spcAft>
+                <a:spcPts val="1200"/>
+              </a:spcAft>
+            </a:pPr>
+            <a:r>
+              <a:rPr sz="2200">
+                <a:solidFill>
+                  <a:srgbClr val="111111"/>
+                </a:solidFill>
+                <a:latin typeface="Calibri"/>
+              </a:rPr>
+              <a:t>•  Then prove it in a 30-question Kahoot at the end of the session</a:t>
             </a:r>
           </a:p>
         </p:txBody>
@@ -20973,7 +21005,7 @@
                           </a:solidFill>
                           <a:latin typeface="Calibri"/>
                         </a:rPr>
-                        <a:t>105 to 110</a:t>
+                        <a:t>105 to 115</a:t>
                       </a:r>
                     </a:p>
                   </a:txBody>
@@ -20995,7 +21027,7 @@
                           </a:solidFill>
                           <a:latin typeface="Calibri"/>
                         </a:rPr>
-                        <a:t>Lab kickoff</a:t>
+                        <a:t>Kahoot</a:t>
                       </a:r>
                     </a:p>
                   </a:txBody>
@@ -21017,7 +21049,7 @@
                           </a:solidFill>
                           <a:latin typeface="Calibri"/>
                         </a:rPr>
-                        <a:t>Task inventory steps shown; finished at home</a:t>
+                        <a:t>As many of the 30 questions as time allows; the rest as a challenge link</a:t>
                       </a:r>
                     </a:p>
                   </a:txBody>
@@ -21041,7 +21073,7 @@
                           </a:solidFill>
                           <a:latin typeface="Calibri"/>
                         </a:rPr>
-                        <a:t>110 to 120</a:t>
+                        <a:t>115 to 120</a:t>
                       </a:r>
                     </a:p>
                   </a:txBody>
@@ -21063,7 +21095,7 @@
                           </a:solidFill>
                           <a:latin typeface="Calibri"/>
                         </a:rPr>
-                        <a:t>Kahoot and wrap</a:t>
+                        <a:t>Lab kickoff and wrap</a:t>
                       </a:r>
                     </a:p>
                   </a:txBody>
@@ -21085,7 +21117,7 @@
                           </a:solidFill>
                           <a:latin typeface="Calibri"/>
                         </a:rPr>
-                        <a:t>As many of the 30 questions as time allows; the rest as a challenge link; key takeaways</a:t>
+                        <a:t>Task inventory steps shown, finished at home; key takeaways</a:t>
                       </a:r>
                     </a:p>
                   </a:txBody>
@@ -28019,7 +28051,7 @@
                 </a:solidFill>
                 <a:latin typeface="Calibri"/>
               </a:rPr>
-              <a:t>Practical lab: your task inventory</a:t>
+              <a:t>Kahoot: knowledge check</a:t>
             </a:r>
           </a:p>
         </p:txBody>
@@ -28054,7 +28086,7 @@
                 </a:solidFill>
                 <a:latin typeface="Calibri"/>
               </a:rPr>
-              <a:t>Steps shown now, finish at home, due before the next session</a:t>
+              <a:t>30 questions, 20 seconds each. Phones out.</a:t>
             </a:r>
           </a:p>
         </p:txBody>
@@ -28089,7 +28121,7 @@
                 </a:solidFill>
                 <a:latin typeface="Calibri"/>
               </a:rPr>
-              <a:t>About 5 minutes</a:t>
+              <a:t>About 10 minutes</a:t>
             </a:r>
           </a:p>
         </p:txBody>
@@ -28256,7 +28288,7 @@
                 </a:solidFill>
                 <a:latin typeface="Calibri"/>
               </a:rPr>
-              <a:t>Lab steps</a:t>
+              <a:t>Join the Kahoot</a:t>
             </a:r>
           </a:p>
         </p:txBody>
@@ -28349,18 +28381,77 @@
           </a:p>
         </p:txBody>
       </p:sp>
-      <p:sp>
-        <p:nvSpPr>
-          <p:cNvPr id="5" name="Oval 4"/>
+      <p:pic>
+        <p:nvPicPr>
+          <p:cNvPr id="5" name="Picture 4" descr="kahoot_logo.png"/>
+          <p:cNvPicPr>
+            <a:picLocks noChangeAspect="1"/>
+          </p:cNvPicPr>
+          <p:nvPr/>
+        </p:nvPicPr>
+        <p:blipFill>
+          <a:blip r:embed="rId2"/>
+          <a:stretch>
+            <a:fillRect/>
+          </a:stretch>
+        </p:blipFill>
+        <p:spPr>
+          <a:xfrm>
+            <a:off x="9315522" y="274320"/>
+            <a:ext cx="2277626" cy="777240"/>
+          </a:xfrm>
+          <a:prstGeom prst="rect">
+            <a:avLst/>
+          </a:prstGeom>
+        </p:spPr>
+      </p:pic>
+      <p:sp>
+        <p:nvSpPr>
+          <p:cNvPr id="6" name="TextBox 5"/>
+          <p:cNvSpPr txBox="1"/>
+          <p:nvPr/>
+        </p:nvSpPr>
+        <p:spPr>
+          <a:xfrm>
+            <a:off x="548640" y="1325880"/>
+            <a:ext cx="5318607" cy="457200"/>
+          </a:xfrm>
+          <a:prstGeom prst="rect">
+            <a:avLst/>
+          </a:prstGeom>
+          <a:noFill/>
+        </p:spPr>
+        <p:txBody>
+          <a:bodyPr wrap="square" anchor="t" lIns="45720" rIns="45720" tIns="27432" bIns="27432">
+            <a:spAutoFit/>
+          </a:bodyPr>
+          <a:lstStyle/>
+          <a:p>
+            <a:pPr algn="l"/>
+            <a:r>
+              <a:rPr sz="2000" b="1" i="0">
+                <a:solidFill>
+                  <a:srgbClr val="111111"/>
+                </a:solidFill>
+                <a:latin typeface="Calibri"/>
+              </a:rPr>
+              <a:t>How to join</a:t>
+            </a:r>
+          </a:p>
+        </p:txBody>
+      </p:sp>
+      <p:sp>
+        <p:nvSpPr>
+          <p:cNvPr id="7" name="Rectangle 6"/>
           <p:cNvSpPr/>
           <p:nvPr/>
         </p:nvSpPr>
         <p:spPr>
           <a:xfrm>
-            <a:off x="548640" y="1399032"/>
-            <a:ext cx="384048" cy="384048"/>
-          </a:xfrm>
-          <a:prstGeom prst="ellipse">
+            <a:off x="548640" y="1801368"/>
+            <a:ext cx="5318607" cy="25400"/>
+          </a:xfrm>
+          <a:prstGeom prst="rect">
             <a:avLst/>
           </a:prstGeom>
           <a:solidFill>
@@ -28386,32 +28477,110 @@
           </a:fontRef>
         </p:style>
         <p:txBody>
-          <a:bodyPr rtlCol="0" anchor="ctr" lIns="0" rIns="0"/>
+          <a:bodyPr rtlCol="0" anchor="ctr"/>
           <a:lstStyle/>
           <a:p>
             <a:pPr algn="ctr"/>
-            <a:r>
-              <a:rPr sz="1300" b="1">
-                <a:solidFill>
-                  <a:srgbClr val="FFFFFF"/>
-                </a:solidFill>
-                <a:latin typeface="Calibri"/>
-              </a:rPr>
-              <a:t>1</a:t>
-            </a:r>
-          </a:p>
-        </p:txBody>
-      </p:sp>
-      <p:sp>
-        <p:nvSpPr>
-          <p:cNvPr id="6" name="TextBox 5"/>
+          </a:p>
+        </p:txBody>
+      </p:sp>
+      <p:sp>
+        <p:nvSpPr>
+          <p:cNvPr id="8" name="TextBox 7"/>
           <p:cNvSpPr txBox="1"/>
           <p:nvPr/>
         </p:nvSpPr>
         <p:spPr>
           <a:xfrm>
-            <a:off x="1097280" y="1325880"/>
-            <a:ext cx="10545775" cy="457200"/>
+            <a:off x="548640" y="1920240"/>
+            <a:ext cx="5318607" cy="4297680"/>
+          </a:xfrm>
+          <a:prstGeom prst="rect">
+            <a:avLst/>
+          </a:prstGeom>
+          <a:noFill/>
+        </p:spPr>
+        <p:txBody>
+          <a:bodyPr wrap="square" lIns="45720" rIns="45720">
+            <a:spAutoFit/>
+          </a:bodyPr>
+          <a:lstStyle/>
+          <a:p>
+            <a:pPr>
+              <a:spcAft>
+                <a:spcPts val="1000"/>
+              </a:spcAft>
+            </a:pPr>
+            <a:r>
+              <a:rPr sz="1800">
+                <a:solidFill>
+                  <a:srgbClr val="111111"/>
+                </a:solidFill>
+                <a:latin typeface="Calibri"/>
+              </a:rPr>
+              <a:t>•  Open kahoot.it on your phone, or the Kahoot app</a:t>
+            </a:r>
+          </a:p>
+          <a:p>
+            <a:pPr>
+              <a:spcAft>
+                <a:spcPts val="1000"/>
+              </a:spcAft>
+            </a:pPr>
+            <a:r>
+              <a:rPr sz="1800">
+                <a:solidFill>
+                  <a:srgbClr val="111111"/>
+                </a:solidFill>
+                <a:latin typeface="Calibri"/>
+              </a:rPr>
+              <a:t>•  Enter the game PIN shown on the screen</a:t>
+            </a:r>
+          </a:p>
+          <a:p>
+            <a:pPr>
+              <a:spcAft>
+                <a:spcPts val="1000"/>
+              </a:spcAft>
+            </a:pPr>
+            <a:r>
+              <a:rPr sz="1800">
+                <a:solidFill>
+                  <a:srgbClr val="111111"/>
+                </a:solidFill>
+                <a:latin typeface="Calibri"/>
+              </a:rPr>
+              <a:t>•  Nickname: your first name</a:t>
+            </a:r>
+          </a:p>
+          <a:p>
+            <a:pPr>
+              <a:spcAft>
+                <a:spcPts val="1000"/>
+              </a:spcAft>
+            </a:pPr>
+            <a:r>
+              <a:rPr sz="1800">
+                <a:solidFill>
+                  <a:srgbClr val="111111"/>
+                </a:solidFill>
+                <a:latin typeface="Calibri"/>
+              </a:rPr>
+              <a:t>•  20 seconds per question; answer on your phone</a:t>
+            </a:r>
+          </a:p>
+        </p:txBody>
+      </p:sp>
+      <p:sp>
+        <p:nvSpPr>
+          <p:cNvPr id="9" name="TextBox 8"/>
+          <p:cNvSpPr txBox="1"/>
+          <p:nvPr/>
+        </p:nvSpPr>
+        <p:spPr>
+          <a:xfrm>
+            <a:off x="6324447" y="1325880"/>
+            <a:ext cx="5318607" cy="457200"/>
           </a:xfrm>
           <a:prstGeom prst="rect">
             <a:avLst/>
@@ -28426,27 +28595,71 @@
           <a:p>
             <a:pPr algn="l"/>
             <a:r>
-              <a:rPr sz="1800" b="1" i="0">
+              <a:rPr sz="2000" b="1" i="0">
                 <a:solidFill>
                   <a:srgbClr val="111111"/>
                 </a:solidFill>
                 <a:latin typeface="Calibri"/>
               </a:rPr>
-              <a:t>1. List ten recurring tasks</a:t>
-            </a:r>
-          </a:p>
-        </p:txBody>
-      </p:sp>
-      <p:sp>
-        <p:nvSpPr>
-          <p:cNvPr id="7" name="TextBox 6"/>
+              <a:t>Fair play notes</a:t>
+            </a:r>
+          </a:p>
+        </p:txBody>
+      </p:sp>
+      <p:sp>
+        <p:nvSpPr>
+          <p:cNvPr id="10" name="Rectangle 9"/>
+          <p:cNvSpPr/>
+          <p:nvPr/>
+        </p:nvSpPr>
+        <p:spPr>
+          <a:xfrm>
+            <a:off x="6324447" y="1801368"/>
+            <a:ext cx="5318607" cy="25400"/>
+          </a:xfrm>
+          <a:prstGeom prst="rect">
+            <a:avLst/>
+          </a:prstGeom>
+          <a:solidFill>
+            <a:srgbClr val="666666"/>
+          </a:solidFill>
+          <a:ln>
+            <a:noFill/>
+          </a:ln>
+          <a:effectLst/>
+        </p:spPr>
+        <p:style>
+          <a:lnRef idx="1">
+            <a:schemeClr val="accent1"/>
+          </a:lnRef>
+          <a:fillRef idx="3">
+            <a:schemeClr val="accent1"/>
+          </a:fillRef>
+          <a:effectRef idx="2">
+            <a:schemeClr val="accent1"/>
+          </a:effectRef>
+          <a:fontRef idx="minor">
+            <a:schemeClr val="lt1"/>
+          </a:fontRef>
+        </p:style>
+        <p:txBody>
+          <a:bodyPr rtlCol="0" anchor="ctr"/>
+          <a:lstStyle/>
+          <a:p>
+            <a:pPr algn="ctr"/>
+          </a:p>
+        </p:txBody>
+      </p:sp>
+      <p:sp>
+        <p:nvSpPr>
+          <p:cNvPr id="11" name="TextBox 10"/>
           <p:cNvSpPr txBox="1"/>
           <p:nvPr/>
         </p:nvSpPr>
         <p:spPr>
           <a:xfrm>
-            <a:off x="1097280" y="1737360"/>
-            <a:ext cx="10545775" cy="493776"/>
+            <a:off x="6324447" y="1920240"/>
+            <a:ext cx="5318607" cy="4297680"/>
           </a:xfrm>
           <a:prstGeom prst="rect">
             <a:avLst/>
@@ -28454,34 +28667,86 @@
           <a:noFill/>
         </p:spPr>
         <p:txBody>
-          <a:bodyPr wrap="square" anchor="t" lIns="45720" rIns="45720" tIns="27432" bIns="27432">
+          <a:bodyPr wrap="square" lIns="45720" rIns="45720">
             <a:spAutoFit/>
           </a:bodyPr>
           <a:lstStyle/>
           <a:p>
-            <a:pPr algn="l"/>
-            <a:r>
-              <a:rPr sz="1500" b="0" i="0">
+            <a:pPr>
+              <a:spcAft>
+                <a:spcPts val="1000"/>
+              </a:spcAft>
+            </a:pPr>
+            <a:r>
+              <a:rPr sz="1800">
                 <a:solidFill>
                   <a:srgbClr val="111111"/>
                 </a:solidFill>
                 <a:latin typeface="Calibri"/>
               </a:rPr>
-              <a:t>Things you do at least weekly. Concrete: 'reply to leave requests', not 'emails'.</a:t>
-            </a:r>
-          </a:p>
-        </p:txBody>
-      </p:sp>
-      <p:sp>
-        <p:nvSpPr>
-          <p:cNvPr id="8" name="Rectangle 7"/>
+              <a:t>•  All four answers are about the same length. The long one is not a hint.</a:t>
+            </a:r>
+          </a:p>
+          <a:p>
+            <a:pPr>
+              <a:spcAft>
+                <a:spcPts val="1000"/>
+              </a:spcAft>
+            </a:pPr>
+            <a:r>
+              <a:rPr sz="1800">
+                <a:solidFill>
+                  <a:srgbClr val="111111"/>
+                </a:solidFill>
+                <a:latin typeface="Calibri"/>
+              </a:rPr>
+              <a:t>•  Correct answers are spread evenly over the four colours.</a:t>
+            </a:r>
+          </a:p>
+          <a:p>
+            <a:pPr>
+              <a:spcAft>
+                <a:spcPts val="1000"/>
+              </a:spcAft>
+            </a:pPr>
+            <a:r>
+              <a:rPr sz="1800">
+                <a:solidFill>
+                  <a:srgbClr val="111111"/>
+                </a:solidFill>
+                <a:latin typeface="Calibri"/>
+              </a:rPr>
+              <a:t>•  We run as many as time allows in the room</a:t>
+            </a:r>
+          </a:p>
+          <a:p>
+            <a:pPr>
+              <a:spcAft>
+                <a:spcPts val="1000"/>
+              </a:spcAft>
+            </a:pPr>
+            <a:r>
+              <a:rPr sz="1800">
+                <a:solidFill>
+                  <a:srgbClr val="111111"/>
+                </a:solidFill>
+                <a:latin typeface="Calibri"/>
+              </a:rPr>
+              <a:t>•  The rest arrive as a Kahoot challenge link for homework</a:t>
+            </a:r>
+          </a:p>
+        </p:txBody>
+      </p:sp>
+      <p:sp>
+        <p:nvSpPr>
+          <p:cNvPr id="12" name="Rectangle 11"/>
           <p:cNvSpPr/>
           <p:nvPr/>
         </p:nvSpPr>
         <p:spPr>
           <a:xfrm>
-            <a:off x="1097280" y="2231136"/>
-            <a:ext cx="10545775" cy="19050"/>
+            <a:off x="548640" y="6309360"/>
+            <a:ext cx="11094415" cy="19050"/>
           </a:xfrm>
           <a:prstGeom prst="rect">
             <a:avLst/>
@@ -28518,67 +28783,14 @@
       </p:sp>
       <p:sp>
         <p:nvSpPr>
-          <p:cNvPr id="9" name="Oval 8"/>
-          <p:cNvSpPr/>
-          <p:nvPr/>
-        </p:nvSpPr>
-        <p:spPr>
-          <a:xfrm>
-            <a:off x="548640" y="2350008"/>
-            <a:ext cx="384048" cy="384048"/>
-          </a:xfrm>
-          <a:prstGeom prst="ellipse">
-            <a:avLst/>
-          </a:prstGeom>
-          <a:solidFill>
-            <a:srgbClr val="F7A11A"/>
-          </a:solidFill>
-          <a:ln>
-            <a:noFill/>
-          </a:ln>
-          <a:effectLst/>
-        </p:spPr>
-        <p:style>
-          <a:lnRef idx="1">
-            <a:schemeClr val="accent1"/>
-          </a:lnRef>
-          <a:fillRef idx="3">
-            <a:schemeClr val="accent1"/>
-          </a:fillRef>
-          <a:effectRef idx="2">
-            <a:schemeClr val="accent1"/>
-          </a:effectRef>
-          <a:fontRef idx="minor">
-            <a:schemeClr val="lt1"/>
-          </a:fontRef>
-        </p:style>
-        <p:txBody>
-          <a:bodyPr rtlCol="0" anchor="ctr" lIns="0" rIns="0"/>
-          <a:lstStyle/>
-          <a:p>
-            <a:pPr algn="ctr"/>
-            <a:r>
-              <a:rPr sz="1300" b="1">
-                <a:solidFill>
-                  <a:srgbClr val="FFFFFF"/>
-                </a:solidFill>
-                <a:latin typeface="Calibri"/>
-              </a:rPr>
-              <a:t>2</a:t>
-            </a:r>
-          </a:p>
-        </p:txBody>
-      </p:sp>
-      <p:sp>
-        <p:nvSpPr>
-          <p:cNvPr id="10" name="TextBox 9"/>
+          <p:cNvPr id="13" name="TextBox 12"/>
           <p:cNvSpPr txBox="1"/>
           <p:nvPr/>
         </p:nvSpPr>
         <p:spPr>
           <a:xfrm>
-            <a:off x="1097280" y="2276856"/>
-            <a:ext cx="10545775" cy="457200"/>
+            <a:off x="548640" y="6355080"/>
+            <a:ext cx="9144000" cy="365760"/>
           </a:xfrm>
           <a:prstGeom prst="rect">
             <a:avLst/>
@@ -28593,145 +28805,13 @@
           <a:p>
             <a:pPr algn="l"/>
             <a:r>
-              <a:rPr sz="1800" b="1" i="0">
-                <a:solidFill>
-                  <a:srgbClr val="111111"/>
-                </a:solidFill>
-                <a:latin typeface="Calibri"/>
-              </a:rPr>
-              <a:t>2. Tag each task</a:t>
-            </a:r>
-          </a:p>
-        </p:txBody>
-      </p:sp>
-      <p:sp>
-        <p:nvSpPr>
-          <p:cNvPr id="11" name="TextBox 10"/>
-          <p:cNvSpPr txBox="1"/>
-          <p:nvPr/>
-        </p:nvSpPr>
-        <p:spPr>
-          <a:xfrm>
-            <a:off x="1097280" y="2688336"/>
-            <a:ext cx="10545775" cy="493776"/>
-          </a:xfrm>
-          <a:prstGeom prst="rect">
-            <a:avLst/>
-          </a:prstGeom>
-          <a:noFill/>
-        </p:spPr>
-        <p:txBody>
-          <a:bodyPr wrap="square" anchor="t" lIns="45720" rIns="45720" tIns="27432" bIns="27432">
-            <a:spAutoFit/>
-          </a:bodyPr>
-          <a:lstStyle/>
-          <a:p>
-            <a:pPr algn="l"/>
-            <a:r>
-              <a:rPr sz="1500" b="0" i="0">
-                <a:solidFill>
-                  <a:srgbClr val="111111"/>
-                </a:solidFill>
-                <a:latin typeface="Calibri"/>
-              </a:rPr>
-              <a:t>Frequency (daily, weekly, monthly); Minutes per occurrence; Judgement needed (none, some, a lot).</a:t>
-            </a:r>
-          </a:p>
-        </p:txBody>
-      </p:sp>
-      <p:sp>
-        <p:nvSpPr>
-          <p:cNvPr id="12" name="Rectangle 11"/>
-          <p:cNvSpPr/>
-          <p:nvPr/>
-        </p:nvSpPr>
-        <p:spPr>
-          <a:xfrm>
-            <a:off x="1097280" y="3182112"/>
-            <a:ext cx="10545775" cy="19050"/>
-          </a:xfrm>
-          <a:prstGeom prst="rect">
-            <a:avLst/>
-          </a:prstGeom>
-          <a:solidFill>
-            <a:srgbClr val="DDDDDD"/>
-          </a:solidFill>
-          <a:ln>
-            <a:noFill/>
-          </a:ln>
-          <a:effectLst/>
-        </p:spPr>
-        <p:style>
-          <a:lnRef idx="1">
-            <a:schemeClr val="accent1"/>
-          </a:lnRef>
-          <a:fillRef idx="3">
-            <a:schemeClr val="accent1"/>
-          </a:fillRef>
-          <a:effectRef idx="2">
-            <a:schemeClr val="accent1"/>
-          </a:effectRef>
-          <a:fontRef idx="minor">
-            <a:schemeClr val="lt1"/>
-          </a:fontRef>
-        </p:style>
-        <p:txBody>
-          <a:bodyPr rtlCol="0" anchor="ctr"/>
-          <a:lstStyle/>
-          <a:p>
-            <a:pPr algn="ctr"/>
-          </a:p>
-        </p:txBody>
-      </p:sp>
-      <p:sp>
-        <p:nvSpPr>
-          <p:cNvPr id="13" name="Oval 12"/>
-          <p:cNvSpPr/>
-          <p:nvPr/>
-        </p:nvSpPr>
-        <p:spPr>
-          <a:xfrm>
-            <a:off x="548640" y="3300984"/>
-            <a:ext cx="384048" cy="384048"/>
-          </a:xfrm>
-          <a:prstGeom prst="ellipse">
-            <a:avLst/>
-          </a:prstGeom>
-          <a:solidFill>
-            <a:srgbClr val="F7A11A"/>
-          </a:solidFill>
-          <a:ln>
-            <a:noFill/>
-          </a:ln>
-          <a:effectLst/>
-        </p:spPr>
-        <p:style>
-          <a:lnRef idx="1">
-            <a:schemeClr val="accent1"/>
-          </a:lnRef>
-          <a:fillRef idx="3">
-            <a:schemeClr val="accent1"/>
-          </a:fillRef>
-          <a:effectRef idx="2">
-            <a:schemeClr val="accent1"/>
-          </a:effectRef>
-          <a:fontRef idx="minor">
-            <a:schemeClr val="lt1"/>
-          </a:fontRef>
-        </p:style>
-        <p:txBody>
-          <a:bodyPr rtlCol="0" anchor="ctr" lIns="0" rIns="0"/>
-          <a:lstStyle/>
-          <a:p>
-            <a:pPr algn="ctr"/>
-            <a:r>
-              <a:rPr sz="1300" b="1">
-                <a:solidFill>
-                  <a:srgbClr val="FFFFFF"/>
-                </a:solidFill>
-                <a:latin typeface="Calibri"/>
-              </a:rPr>
-              <a:t>3</a:t>
+              <a:rPr sz="1000" b="0" i="0">
+                <a:solidFill>
+                  <a:srgbClr val="666666"/>
+                </a:solidFill>
+                <a:latin typeface="Calibri"/>
+              </a:rPr>
+              <a:t>IEEE CS Region 8 AI Caravan 2026 · AI Administrator · Day 1 · Session 1</a:t>
             </a:r>
           </a:p>
         </p:txBody>
@@ -28739,489 +28819,6 @@
       <p:sp>
         <p:nvSpPr>
           <p:cNvPr id="14" name="TextBox 13"/>
-          <p:cNvSpPr txBox="1"/>
-          <p:nvPr/>
-        </p:nvSpPr>
-        <p:spPr>
-          <a:xfrm>
-            <a:off x="1097280" y="3227832"/>
-            <a:ext cx="10545775" cy="457200"/>
-          </a:xfrm>
-          <a:prstGeom prst="rect">
-            <a:avLst/>
-          </a:prstGeom>
-          <a:noFill/>
-        </p:spPr>
-        <p:txBody>
-          <a:bodyPr wrap="square" anchor="t" lIns="45720" rIns="45720" tIns="27432" bIns="27432">
-            <a:spAutoFit/>
-          </a:bodyPr>
-          <a:lstStyle/>
-          <a:p>
-            <a:pPr algn="l"/>
-            <a:r>
-              <a:rPr sz="1800" b="1" i="0">
-                <a:solidFill>
-                  <a:srgbClr val="111111"/>
-                </a:solidFill>
-                <a:latin typeface="Calibri"/>
-              </a:rPr>
-              <a:t>3. Classify the design</a:t>
-            </a:r>
-          </a:p>
-        </p:txBody>
-      </p:sp>
-      <p:sp>
-        <p:nvSpPr>
-          <p:cNvPr id="15" name="TextBox 14"/>
-          <p:cNvSpPr txBox="1"/>
-          <p:nvPr/>
-        </p:nvSpPr>
-        <p:spPr>
-          <a:xfrm>
-            <a:off x="1097280" y="3639312"/>
-            <a:ext cx="10545775" cy="493776"/>
-          </a:xfrm>
-          <a:prstGeom prst="rect">
-            <a:avLst/>
-          </a:prstGeom>
-          <a:noFill/>
-        </p:spPr>
-        <p:txBody>
-          <a:bodyPr wrap="square" anchor="t" lIns="45720" rIns="45720" tIns="27432" bIns="27432">
-            <a:spAutoFit/>
-          </a:bodyPr>
-          <a:lstStyle/>
-          <a:p>
-            <a:pPr algn="l"/>
-            <a:r>
-              <a:rPr sz="1500" b="0" i="0">
-                <a:solidFill>
-                  <a:srgbClr val="111111"/>
-                </a:solidFill>
-                <a:latin typeface="Calibri"/>
-              </a:rPr>
-              <a:t>Automation, Workflow with AI step, Agent, or Keep human. Use the five-tasks table as a guide.</a:t>
-            </a:r>
-          </a:p>
-        </p:txBody>
-      </p:sp>
-      <p:sp>
-        <p:nvSpPr>
-          <p:cNvPr id="16" name="Rectangle 15"/>
-          <p:cNvSpPr/>
-          <p:nvPr/>
-        </p:nvSpPr>
-        <p:spPr>
-          <a:xfrm>
-            <a:off x="1097280" y="4133088"/>
-            <a:ext cx="10545775" cy="19050"/>
-          </a:xfrm>
-          <a:prstGeom prst="rect">
-            <a:avLst/>
-          </a:prstGeom>
-          <a:solidFill>
-            <a:srgbClr val="DDDDDD"/>
-          </a:solidFill>
-          <a:ln>
-            <a:noFill/>
-          </a:ln>
-          <a:effectLst/>
-        </p:spPr>
-        <p:style>
-          <a:lnRef idx="1">
-            <a:schemeClr val="accent1"/>
-          </a:lnRef>
-          <a:fillRef idx="3">
-            <a:schemeClr val="accent1"/>
-          </a:fillRef>
-          <a:effectRef idx="2">
-            <a:schemeClr val="accent1"/>
-          </a:effectRef>
-          <a:fontRef idx="minor">
-            <a:schemeClr val="lt1"/>
-          </a:fontRef>
-        </p:style>
-        <p:txBody>
-          <a:bodyPr rtlCol="0" anchor="ctr"/>
-          <a:lstStyle/>
-          <a:p>
-            <a:pPr algn="ctr"/>
-          </a:p>
-        </p:txBody>
-      </p:sp>
-      <p:sp>
-        <p:nvSpPr>
-          <p:cNvPr id="17" name="Oval 16"/>
-          <p:cNvSpPr/>
-          <p:nvPr/>
-        </p:nvSpPr>
-        <p:spPr>
-          <a:xfrm>
-            <a:off x="548640" y="4251960"/>
-            <a:ext cx="384048" cy="384048"/>
-          </a:xfrm>
-          <a:prstGeom prst="ellipse">
-            <a:avLst/>
-          </a:prstGeom>
-          <a:solidFill>
-            <a:srgbClr val="F7A11A"/>
-          </a:solidFill>
-          <a:ln>
-            <a:noFill/>
-          </a:ln>
-          <a:effectLst/>
-        </p:spPr>
-        <p:style>
-          <a:lnRef idx="1">
-            <a:schemeClr val="accent1"/>
-          </a:lnRef>
-          <a:fillRef idx="3">
-            <a:schemeClr val="accent1"/>
-          </a:fillRef>
-          <a:effectRef idx="2">
-            <a:schemeClr val="accent1"/>
-          </a:effectRef>
-          <a:fontRef idx="minor">
-            <a:schemeClr val="lt1"/>
-          </a:fontRef>
-        </p:style>
-        <p:txBody>
-          <a:bodyPr rtlCol="0" anchor="ctr" lIns="0" rIns="0"/>
-          <a:lstStyle/>
-          <a:p>
-            <a:pPr algn="ctr"/>
-            <a:r>
-              <a:rPr sz="1300" b="1">
-                <a:solidFill>
-                  <a:srgbClr val="FFFFFF"/>
-                </a:solidFill>
-                <a:latin typeface="Calibri"/>
-              </a:rPr>
-              <a:t>4</a:t>
-            </a:r>
-          </a:p>
-        </p:txBody>
-      </p:sp>
-      <p:sp>
-        <p:nvSpPr>
-          <p:cNvPr id="18" name="TextBox 17"/>
-          <p:cNvSpPr txBox="1"/>
-          <p:nvPr/>
-        </p:nvSpPr>
-        <p:spPr>
-          <a:xfrm>
-            <a:off x="1097280" y="4178808"/>
-            <a:ext cx="10545775" cy="457200"/>
-          </a:xfrm>
-          <a:prstGeom prst="rect">
-            <a:avLst/>
-          </a:prstGeom>
-          <a:noFill/>
-        </p:spPr>
-        <p:txBody>
-          <a:bodyPr wrap="square" anchor="t" lIns="45720" rIns="45720" tIns="27432" bIns="27432">
-            <a:spAutoFit/>
-          </a:bodyPr>
-          <a:lstStyle/>
-          <a:p>
-            <a:pPr algn="l"/>
-            <a:r>
-              <a:rPr sz="1800" b="1" i="0">
-                <a:solidFill>
-                  <a:srgbClr val="111111"/>
-                </a:solidFill>
-                <a:latin typeface="Calibri"/>
-              </a:rPr>
-              <a:t>4. Ask your assistant to challenge you</a:t>
-            </a:r>
-          </a:p>
-        </p:txBody>
-      </p:sp>
-      <p:sp>
-        <p:nvSpPr>
-          <p:cNvPr id="19" name="TextBox 18"/>
-          <p:cNvSpPr txBox="1"/>
-          <p:nvPr/>
-        </p:nvSpPr>
-        <p:spPr>
-          <a:xfrm>
-            <a:off x="1097280" y="4590288"/>
-            <a:ext cx="10545775" cy="493776"/>
-          </a:xfrm>
-          <a:prstGeom prst="rect">
-            <a:avLst/>
-          </a:prstGeom>
-          <a:noFill/>
-        </p:spPr>
-        <p:txBody>
-          <a:bodyPr wrap="square" anchor="t" lIns="45720" rIns="45720" tIns="27432" bIns="27432">
-            <a:spAutoFit/>
-          </a:bodyPr>
-          <a:lstStyle/>
-          <a:p>
-            <a:pPr algn="l"/>
-            <a:r>
-              <a:rPr sz="1500" b="0" i="0">
-                <a:solidFill>
-                  <a:srgbClr val="111111"/>
-                </a:solidFill>
-                <a:latin typeface="Calibri"/>
-              </a:rPr>
-              <a:t>Paste the table with the prompt on the next slide. Note where it disagrees.</a:t>
-            </a:r>
-          </a:p>
-        </p:txBody>
-      </p:sp>
-      <p:sp>
-        <p:nvSpPr>
-          <p:cNvPr id="20" name="Rectangle 19"/>
-          <p:cNvSpPr/>
-          <p:nvPr/>
-        </p:nvSpPr>
-        <p:spPr>
-          <a:xfrm>
-            <a:off x="1097280" y="5084064"/>
-            <a:ext cx="10545775" cy="19050"/>
-          </a:xfrm>
-          <a:prstGeom prst="rect">
-            <a:avLst/>
-          </a:prstGeom>
-          <a:solidFill>
-            <a:srgbClr val="DDDDDD"/>
-          </a:solidFill>
-          <a:ln>
-            <a:noFill/>
-          </a:ln>
-          <a:effectLst/>
-        </p:spPr>
-        <p:style>
-          <a:lnRef idx="1">
-            <a:schemeClr val="accent1"/>
-          </a:lnRef>
-          <a:fillRef idx="3">
-            <a:schemeClr val="accent1"/>
-          </a:fillRef>
-          <a:effectRef idx="2">
-            <a:schemeClr val="accent1"/>
-          </a:effectRef>
-          <a:fontRef idx="minor">
-            <a:schemeClr val="lt1"/>
-          </a:fontRef>
-        </p:style>
-        <p:txBody>
-          <a:bodyPr rtlCol="0" anchor="ctr"/>
-          <a:lstStyle/>
-          <a:p>
-            <a:pPr algn="ctr"/>
-          </a:p>
-        </p:txBody>
-      </p:sp>
-      <p:sp>
-        <p:nvSpPr>
-          <p:cNvPr id="21" name="Oval 20"/>
-          <p:cNvSpPr/>
-          <p:nvPr/>
-        </p:nvSpPr>
-        <p:spPr>
-          <a:xfrm>
-            <a:off x="548640" y="5202936"/>
-            <a:ext cx="384048" cy="384048"/>
-          </a:xfrm>
-          <a:prstGeom prst="ellipse">
-            <a:avLst/>
-          </a:prstGeom>
-          <a:solidFill>
-            <a:srgbClr val="F7A11A"/>
-          </a:solidFill>
-          <a:ln>
-            <a:noFill/>
-          </a:ln>
-          <a:effectLst/>
-        </p:spPr>
-        <p:style>
-          <a:lnRef idx="1">
-            <a:schemeClr val="accent1"/>
-          </a:lnRef>
-          <a:fillRef idx="3">
-            <a:schemeClr val="accent1"/>
-          </a:fillRef>
-          <a:effectRef idx="2">
-            <a:schemeClr val="accent1"/>
-          </a:effectRef>
-          <a:fontRef idx="minor">
-            <a:schemeClr val="lt1"/>
-          </a:fontRef>
-        </p:style>
-        <p:txBody>
-          <a:bodyPr rtlCol="0" anchor="ctr" lIns="0" rIns="0"/>
-          <a:lstStyle/>
-          <a:p>
-            <a:pPr algn="ctr"/>
-            <a:r>
-              <a:rPr sz="1300" b="1">
-                <a:solidFill>
-                  <a:srgbClr val="FFFFFF"/>
-                </a:solidFill>
-                <a:latin typeface="Calibri"/>
-              </a:rPr>
-              <a:t>5</a:t>
-            </a:r>
-          </a:p>
-        </p:txBody>
-      </p:sp>
-      <p:sp>
-        <p:nvSpPr>
-          <p:cNvPr id="22" name="TextBox 21"/>
-          <p:cNvSpPr txBox="1"/>
-          <p:nvPr/>
-        </p:nvSpPr>
-        <p:spPr>
-          <a:xfrm>
-            <a:off x="1097280" y="5129784"/>
-            <a:ext cx="10545775" cy="457200"/>
-          </a:xfrm>
-          <a:prstGeom prst="rect">
-            <a:avLst/>
-          </a:prstGeom>
-          <a:noFill/>
-        </p:spPr>
-        <p:txBody>
-          <a:bodyPr wrap="square" anchor="t" lIns="45720" rIns="45720" tIns="27432" bIns="27432">
-            <a:spAutoFit/>
-          </a:bodyPr>
-          <a:lstStyle/>
-          <a:p>
-            <a:pPr algn="l"/>
-            <a:r>
-              <a:rPr sz="1800" b="1" i="0">
-                <a:solidFill>
-                  <a:srgbClr val="111111"/>
-                </a:solidFill>
-                <a:latin typeface="Calibri"/>
-              </a:rPr>
-              <a:t>5. Pick your course task</a:t>
-            </a:r>
-          </a:p>
-        </p:txBody>
-      </p:sp>
-      <p:sp>
-        <p:nvSpPr>
-          <p:cNvPr id="23" name="TextBox 22"/>
-          <p:cNvSpPr txBox="1"/>
-          <p:nvPr/>
-        </p:nvSpPr>
-        <p:spPr>
-          <a:xfrm>
-            <a:off x="1097280" y="5541264"/>
-            <a:ext cx="10545775" cy="493776"/>
-          </a:xfrm>
-          <a:prstGeom prst="rect">
-            <a:avLst/>
-          </a:prstGeom>
-          <a:noFill/>
-        </p:spPr>
-        <p:txBody>
-          <a:bodyPr wrap="square" anchor="t" lIns="45720" rIns="45720" tIns="27432" bIns="27432">
-            <a:spAutoFit/>
-          </a:bodyPr>
-          <a:lstStyle/>
-          <a:p>
-            <a:pPr algn="l"/>
-            <a:r>
-              <a:rPr sz="1500" b="0" i="0">
-                <a:solidFill>
-                  <a:srgbClr val="111111"/>
-                </a:solidFill>
-                <a:latin typeface="Calibri"/>
-              </a:rPr>
-              <a:t>One 'Workflow with AI step' task taking 30+ minutes a week. You will map, build and control it over the course.</a:t>
-            </a:r>
-          </a:p>
-        </p:txBody>
-      </p:sp>
-      <p:sp>
-        <p:nvSpPr>
-          <p:cNvPr id="24" name="Rectangle 23"/>
-          <p:cNvSpPr/>
-          <p:nvPr/>
-        </p:nvSpPr>
-        <p:spPr>
-          <a:xfrm>
-            <a:off x="548640" y="6309360"/>
-            <a:ext cx="11094415" cy="19050"/>
-          </a:xfrm>
-          <a:prstGeom prst="rect">
-            <a:avLst/>
-          </a:prstGeom>
-          <a:solidFill>
-            <a:srgbClr val="DDDDDD"/>
-          </a:solidFill>
-          <a:ln>
-            <a:noFill/>
-          </a:ln>
-          <a:effectLst/>
-        </p:spPr>
-        <p:style>
-          <a:lnRef idx="1">
-            <a:schemeClr val="accent1"/>
-          </a:lnRef>
-          <a:fillRef idx="3">
-            <a:schemeClr val="accent1"/>
-          </a:fillRef>
-          <a:effectRef idx="2">
-            <a:schemeClr val="accent1"/>
-          </a:effectRef>
-          <a:fontRef idx="minor">
-            <a:schemeClr val="lt1"/>
-          </a:fontRef>
-        </p:style>
-        <p:txBody>
-          <a:bodyPr rtlCol="0" anchor="ctr"/>
-          <a:lstStyle/>
-          <a:p>
-            <a:pPr algn="ctr"/>
-          </a:p>
-        </p:txBody>
-      </p:sp>
-      <p:sp>
-        <p:nvSpPr>
-          <p:cNvPr id="25" name="TextBox 24"/>
-          <p:cNvSpPr txBox="1"/>
-          <p:nvPr/>
-        </p:nvSpPr>
-        <p:spPr>
-          <a:xfrm>
-            <a:off x="548640" y="6355080"/>
-            <a:ext cx="9144000" cy="365760"/>
-          </a:xfrm>
-          <a:prstGeom prst="rect">
-            <a:avLst/>
-          </a:prstGeom>
-          <a:noFill/>
-        </p:spPr>
-        <p:txBody>
-          <a:bodyPr wrap="square" anchor="t" lIns="45720" rIns="45720" tIns="27432" bIns="27432">
-            <a:spAutoFit/>
-          </a:bodyPr>
-          <a:lstStyle/>
-          <a:p>
-            <a:pPr algn="l"/>
-            <a:r>
-              <a:rPr sz="1000" b="0" i="0">
-                <a:solidFill>
-                  <a:srgbClr val="666666"/>
-                </a:solidFill>
-                <a:latin typeface="Calibri"/>
-              </a:rPr>
-              <a:t>IEEE CS Region 8 AI Caravan 2026 · AI Administrator · Day 1 · Session 1</a:t>
-            </a:r>
-          </a:p>
-        </p:txBody>
-      </p:sp>
-      <p:sp>
-        <p:nvSpPr>
-          <p:cNvPr id="26" name="TextBox 25"/>
           <p:cNvSpPr txBox="1"/>
           <p:nvPr/>
         </p:nvSpPr>
@@ -29280,8 +28877,8 @@
         </p:nvSpPr>
         <p:spPr>
           <a:xfrm>
-            <a:off x="548640" y="365760"/>
-            <a:ext cx="11094415" cy="777240"/>
+            <a:off x="548640" y="2011680"/>
+            <a:ext cx="11094415" cy="457200"/>
           </a:xfrm>
           <a:prstGeom prst="rect">
             <a:avLst/>
@@ -29289,20 +28886,20 @@
           <a:noFill/>
         </p:spPr>
         <p:txBody>
-          <a:bodyPr wrap="square" anchor="b" lIns="45720" rIns="45720" tIns="27432" bIns="27432">
+          <a:bodyPr wrap="square" anchor="t" lIns="45720" rIns="45720" tIns="27432" bIns="27432">
             <a:spAutoFit/>
           </a:bodyPr>
           <a:lstStyle/>
           <a:p>
             <a:pPr algn="l"/>
             <a:r>
-              <a:rPr sz="3000" b="1" i="0">
-                <a:solidFill>
-                  <a:srgbClr val="111111"/>
-                </a:solidFill>
-                <a:latin typeface="Calibri"/>
-              </a:rPr>
-              <a:t>Step 4: the challenge prompt</a:t>
+              <a:rPr sz="1400" b="0" i="0">
+                <a:solidFill>
+                  <a:srgbClr val="666666"/>
+                </a:solidFill>
+                <a:latin typeface="Calibri"/>
+              </a:rPr>
+              <a:t>Section · minute 115</a:t>
             </a:r>
           </a:p>
         </p:txBody>
@@ -29315,8 +28912,8 @@
         </p:nvSpPr>
         <p:spPr>
           <a:xfrm>
-            <a:off x="548640" y="1115568"/>
-            <a:ext cx="1097280" cy="38100"/>
+            <a:off x="548640" y="2514600"/>
+            <a:ext cx="1463040" cy="50800"/>
           </a:xfrm>
           <a:prstGeom prst="rect">
             <a:avLst/>
@@ -29353,91 +28950,71 @@
       </p:sp>
       <p:sp>
         <p:nvSpPr>
-          <p:cNvPr id="4" name="Rectangle 3"/>
-          <p:cNvSpPr/>
-          <p:nvPr/>
-        </p:nvSpPr>
-        <p:spPr>
-          <a:xfrm>
-            <a:off x="1645920" y="1115568"/>
-            <a:ext cx="9997135" cy="19050"/>
-          </a:xfrm>
-          <a:prstGeom prst="rect">
-            <a:avLst/>
-          </a:prstGeom>
-          <a:solidFill>
-            <a:srgbClr val="DDDDDD"/>
-          </a:solidFill>
-          <a:ln>
-            <a:noFill/>
-          </a:ln>
-          <a:effectLst/>
-        </p:spPr>
-        <p:style>
-          <a:lnRef idx="1">
-            <a:schemeClr val="accent1"/>
-          </a:lnRef>
-          <a:fillRef idx="3">
-            <a:schemeClr val="accent1"/>
-          </a:fillRef>
-          <a:effectRef idx="2">
-            <a:schemeClr val="accent1"/>
-          </a:effectRef>
-          <a:fontRef idx="minor">
-            <a:schemeClr val="lt1"/>
-          </a:fontRef>
-        </p:style>
-        <p:txBody>
-          <a:bodyPr rtlCol="0" anchor="ctr"/>
-          <a:lstStyle/>
-          <a:p>
-            <a:pPr algn="ctr"/>
-          </a:p>
-        </p:txBody>
-      </p:sp>
-      <p:sp>
-        <p:nvSpPr>
-          <p:cNvPr id="5" name="Rectangle 4"/>
-          <p:cNvSpPr/>
-          <p:nvPr/>
-        </p:nvSpPr>
-        <p:spPr>
-          <a:xfrm>
-            <a:off x="548640" y="1371600"/>
-            <a:ext cx="11094415" cy="4663440"/>
-          </a:xfrm>
-          <a:prstGeom prst="rect">
-            <a:avLst/>
-          </a:prstGeom>
-          <a:solidFill>
-            <a:srgbClr val="F2F2F2"/>
-          </a:solidFill>
-          <a:ln>
-            <a:solidFill>
-              <a:srgbClr val="DDDDDD"/>
-            </a:solidFill>
-          </a:ln>
-          <a:effectLst/>
-        </p:spPr>
-        <p:style>
-          <a:lnRef idx="1">
-            <a:schemeClr val="accent1"/>
-          </a:lnRef>
-          <a:fillRef idx="3">
-            <a:schemeClr val="accent1"/>
-          </a:fillRef>
-          <a:effectRef idx="2">
-            <a:schemeClr val="accent1"/>
-          </a:effectRef>
-          <a:fontRef idx="minor">
-            <a:schemeClr val="lt1"/>
-          </a:fontRef>
-        </p:style>
-        <p:txBody>
-          <a:bodyPr rtlCol="0" anchor="ctr"/>
-          <a:lstStyle/>
-          <a:p>
-            <a:pPr algn="ctr"/>
+          <p:cNvPr id="4" name="TextBox 3"/>
+          <p:cNvSpPr txBox="1"/>
+          <p:nvPr/>
+        </p:nvSpPr>
+        <p:spPr>
+          <a:xfrm>
+            <a:off x="548640" y="2651760"/>
+            <a:ext cx="11094415" cy="1371600"/>
+          </a:xfrm>
+          <a:prstGeom prst="rect">
+            <a:avLst/>
+          </a:prstGeom>
+          <a:noFill/>
+        </p:spPr>
+        <p:txBody>
+          <a:bodyPr wrap="square" anchor="t" lIns="45720" rIns="45720" tIns="27432" bIns="27432">
+            <a:spAutoFit/>
+          </a:bodyPr>
+          <a:lstStyle/>
+          <a:p>
+            <a:pPr algn="l"/>
+            <a:r>
+              <a:rPr sz="3800" b="1" i="0">
+                <a:solidFill>
+                  <a:srgbClr val="111111"/>
+                </a:solidFill>
+                <a:latin typeface="Calibri"/>
+              </a:rPr>
+              <a:t>Practical lab: your task inventory</a:t>
+            </a:r>
+          </a:p>
+        </p:txBody>
+      </p:sp>
+      <p:sp>
+        <p:nvSpPr>
+          <p:cNvPr id="5" name="TextBox 4"/>
+          <p:cNvSpPr txBox="1"/>
+          <p:nvPr/>
+        </p:nvSpPr>
+        <p:spPr>
+          <a:xfrm>
+            <a:off x="548640" y="4023360"/>
+            <a:ext cx="11094415" cy="822960"/>
+          </a:xfrm>
+          <a:prstGeom prst="rect">
+            <a:avLst/>
+          </a:prstGeom>
+          <a:noFill/>
+        </p:spPr>
+        <p:txBody>
+          <a:bodyPr wrap="square" anchor="t" lIns="45720" rIns="45720" tIns="27432" bIns="27432">
+            <a:spAutoFit/>
+          </a:bodyPr>
+          <a:lstStyle/>
+          <a:p>
+            <a:pPr algn="l"/>
+            <a:r>
+              <a:rPr sz="2000" b="0" i="0">
+                <a:solidFill>
+                  <a:srgbClr val="666666"/>
+                </a:solidFill>
+                <a:latin typeface="Calibri"/>
+              </a:rPr>
+              <a:t>Steps shown now, finish at home, due before the next session</a:t>
+            </a:r>
           </a:p>
         </p:txBody>
       </p:sp>
@@ -29449,8 +29026,8 @@
         </p:nvSpPr>
         <p:spPr>
           <a:xfrm>
-            <a:off x="822960" y="1554480"/>
-            <a:ext cx="10545775" cy="4297680"/>
+            <a:off x="548640" y="4846320"/>
+            <a:ext cx="11094415" cy="457200"/>
           </a:xfrm>
           <a:prstGeom prst="rect">
             <a:avLst/>
@@ -29465,61 +29042,13 @@
           <a:p>
             <a:pPr algn="l"/>
             <a:r>
-              <a:rPr sz="1600" b="0" i="0">
-                <a:solidFill>
-                  <a:srgbClr val="111111"/>
-                </a:solidFill>
-                <a:latin typeface="Courier New"/>
-              </a:rPr>
-              <a:t>You are an operations consultant. Here is a table of my recurring tasks with my proposed design for each</a:t>
-            </a:r>
-          </a:p>
-          <a:p>
-            <a:pPr algn="l"/>
-            <a:r>
-              <a:rPr sz="1600" b="0" i="0">
-                <a:solidFill>
-                  <a:srgbClr val="111111"/>
-                </a:solidFill>
-                <a:latin typeface="Courier New"/>
-              </a:rPr>
-              <a:t>(Automation, Workflow with AI step, Agent, Keep human). For each row, say whether you agree, and if not, why.</a:t>
-            </a:r>
-          </a:p>
-          <a:p>
-            <a:pPr algn="l"/>
-            <a:r>
-              <a:rPr sz="1600" b="0" i="0">
-                <a:solidFill>
-                  <a:srgbClr val="111111"/>
-                </a:solidFill>
-                <a:latin typeface="Courier New"/>
-              </a:rPr>
-              <a:t>Then rank the top three tasks by time saved per week. Be brief.</a:t>
-            </a:r>
-          </a:p>
-          <a:p>
-            <a:pPr algn="l"/>
-            <a:r>
-              <a:rPr sz="1600" b="0" i="0">
-                <a:solidFill>
-                  <a:srgbClr val="111111"/>
-                </a:solidFill>
-                <a:latin typeface="Courier New"/>
-              </a:rPr>
-              <a:t/>
-            </a:r>
-          </a:p>
-          <a:p>
-            <a:pPr algn="l"/>
-            <a:r>
-              <a:rPr sz="1600" b="0" i="0">
-                <a:solidFill>
-                  <a:srgbClr val="111111"/>
-                </a:solidFill>
-                <a:latin typeface="Courier New"/>
-              </a:rPr>
-              <a:t>[paste your table here]</a:t>
+              <a:rPr sz="1400" b="0" i="0">
+                <a:solidFill>
+                  <a:srgbClr val="666666"/>
+                </a:solidFill>
+                <a:latin typeface="Calibri"/>
+              </a:rPr>
+              <a:t>About 5 minutes</a:t>
             </a:r>
           </a:p>
         </p:txBody>
@@ -29686,7 +29215,7 @@
                 </a:solidFill>
                 <a:latin typeface="Calibri"/>
               </a:rPr>
-              <a:t>Deliverable</a:t>
+              <a:t>Lab steps</a:t>
             </a:r>
           </a:p>
         </p:txBody>
@@ -29781,16 +29310,16 @@
       </p:sp>
       <p:sp>
         <p:nvSpPr>
-          <p:cNvPr id="5" name="Rectangle 4"/>
+          <p:cNvPr id="5" name="Oval 4"/>
           <p:cNvSpPr/>
           <p:nvPr/>
         </p:nvSpPr>
         <p:spPr>
           <a:xfrm>
-            <a:off x="548640" y="1783080"/>
-            <a:ext cx="76200" cy="2926080"/>
-          </a:xfrm>
-          <a:prstGeom prst="rect">
+            <a:off x="548640" y="1399032"/>
+            <a:ext cx="384048" cy="384048"/>
+          </a:xfrm>
+          <a:prstGeom prst="ellipse">
             <a:avLst/>
           </a:prstGeom>
           <a:solidFill>
@@ -29816,10 +29345,19 @@
           </a:fontRef>
         </p:style>
         <p:txBody>
-          <a:bodyPr rtlCol="0" anchor="ctr"/>
+          <a:bodyPr rtlCol="0" anchor="ctr" lIns="0" rIns="0"/>
           <a:lstStyle/>
           <a:p>
             <a:pPr algn="ctr"/>
+            <a:r>
+              <a:rPr sz="1300" b="1">
+                <a:solidFill>
+                  <a:srgbClr val="FFFFFF"/>
+                </a:solidFill>
+                <a:latin typeface="Calibri"/>
+              </a:rPr>
+              <a:t>1</a:t>
+            </a:r>
           </a:p>
         </p:txBody>
       </p:sp>
@@ -29831,8 +29369,8 @@
         </p:nvSpPr>
         <p:spPr>
           <a:xfrm>
-            <a:off x="914400" y="1783080"/>
-            <a:ext cx="10728655" cy="2926080"/>
+            <a:off x="1097280" y="1325880"/>
+            <a:ext cx="10545775" cy="457200"/>
           </a:xfrm>
           <a:prstGeom prst="rect">
             <a:avLst/>
@@ -29840,34 +29378,69 @@
           <a:noFill/>
         </p:spPr>
         <p:txBody>
-          <a:bodyPr wrap="square" anchor="ctr" lIns="45720" rIns="45720" tIns="27432" bIns="27432">
+          <a:bodyPr wrap="square" anchor="t" lIns="45720" rIns="45720" tIns="27432" bIns="27432">
             <a:spAutoFit/>
           </a:bodyPr>
           <a:lstStyle/>
           <a:p>
             <a:pPr algn="l"/>
             <a:r>
-              <a:rPr sz="2800" b="0" i="0">
+              <a:rPr sz="1800" b="1" i="0">
                 <a:solidFill>
                   <a:srgbClr val="111111"/>
                 </a:solidFill>
                 <a:latin typeface="Calibri"/>
               </a:rPr>
-              <a:t>A one-page task inventory (ten rows, four columns) with your chosen course task highlighted, saved as M1-task-inventory in your course folder. Bring it to the next session.</a:t>
-            </a:r>
-          </a:p>
-        </p:txBody>
-      </p:sp>
-      <p:sp>
-        <p:nvSpPr>
-          <p:cNvPr id="7" name="Rectangle 6"/>
+              <a:t>1. List ten recurring tasks</a:t>
+            </a:r>
+          </a:p>
+        </p:txBody>
+      </p:sp>
+      <p:sp>
+        <p:nvSpPr>
+          <p:cNvPr id="7" name="TextBox 6"/>
+          <p:cNvSpPr txBox="1"/>
+          <p:nvPr/>
+        </p:nvSpPr>
+        <p:spPr>
+          <a:xfrm>
+            <a:off x="1097280" y="1737360"/>
+            <a:ext cx="10545775" cy="493776"/>
+          </a:xfrm>
+          <a:prstGeom prst="rect">
+            <a:avLst/>
+          </a:prstGeom>
+          <a:noFill/>
+        </p:spPr>
+        <p:txBody>
+          <a:bodyPr wrap="square" anchor="t" lIns="45720" rIns="45720" tIns="27432" bIns="27432">
+            <a:spAutoFit/>
+          </a:bodyPr>
+          <a:lstStyle/>
+          <a:p>
+            <a:pPr algn="l"/>
+            <a:r>
+              <a:rPr sz="1500" b="0" i="0">
+                <a:solidFill>
+                  <a:srgbClr val="111111"/>
+                </a:solidFill>
+                <a:latin typeface="Calibri"/>
+              </a:rPr>
+              <a:t>Things you do at least weekly. Concrete: 'reply to leave requests', not 'emails'.</a:t>
+            </a:r>
+          </a:p>
+        </p:txBody>
+      </p:sp>
+      <p:sp>
+        <p:nvSpPr>
+          <p:cNvPr id="8" name="Rectangle 7"/>
           <p:cNvSpPr/>
           <p:nvPr/>
         </p:nvSpPr>
         <p:spPr>
           <a:xfrm>
-            <a:off x="548640" y="6309360"/>
-            <a:ext cx="11094415" cy="19050"/>
+            <a:off x="1097280" y="2231136"/>
+            <a:ext cx="10545775" cy="19050"/>
           </a:xfrm>
           <a:prstGeom prst="rect">
             <a:avLst/>
@@ -29904,7 +29477,675 @@
       </p:sp>
       <p:sp>
         <p:nvSpPr>
-          <p:cNvPr id="8" name="TextBox 7"/>
+          <p:cNvPr id="9" name="Oval 8"/>
+          <p:cNvSpPr/>
+          <p:nvPr/>
+        </p:nvSpPr>
+        <p:spPr>
+          <a:xfrm>
+            <a:off x="548640" y="2350008"/>
+            <a:ext cx="384048" cy="384048"/>
+          </a:xfrm>
+          <a:prstGeom prst="ellipse">
+            <a:avLst/>
+          </a:prstGeom>
+          <a:solidFill>
+            <a:srgbClr val="F7A11A"/>
+          </a:solidFill>
+          <a:ln>
+            <a:noFill/>
+          </a:ln>
+          <a:effectLst/>
+        </p:spPr>
+        <p:style>
+          <a:lnRef idx="1">
+            <a:schemeClr val="accent1"/>
+          </a:lnRef>
+          <a:fillRef idx="3">
+            <a:schemeClr val="accent1"/>
+          </a:fillRef>
+          <a:effectRef idx="2">
+            <a:schemeClr val="accent1"/>
+          </a:effectRef>
+          <a:fontRef idx="minor">
+            <a:schemeClr val="lt1"/>
+          </a:fontRef>
+        </p:style>
+        <p:txBody>
+          <a:bodyPr rtlCol="0" anchor="ctr" lIns="0" rIns="0"/>
+          <a:lstStyle/>
+          <a:p>
+            <a:pPr algn="ctr"/>
+            <a:r>
+              <a:rPr sz="1300" b="1">
+                <a:solidFill>
+                  <a:srgbClr val="FFFFFF"/>
+                </a:solidFill>
+                <a:latin typeface="Calibri"/>
+              </a:rPr>
+              <a:t>2</a:t>
+            </a:r>
+          </a:p>
+        </p:txBody>
+      </p:sp>
+      <p:sp>
+        <p:nvSpPr>
+          <p:cNvPr id="10" name="TextBox 9"/>
+          <p:cNvSpPr txBox="1"/>
+          <p:nvPr/>
+        </p:nvSpPr>
+        <p:spPr>
+          <a:xfrm>
+            <a:off x="1097280" y="2276856"/>
+            <a:ext cx="10545775" cy="457200"/>
+          </a:xfrm>
+          <a:prstGeom prst="rect">
+            <a:avLst/>
+          </a:prstGeom>
+          <a:noFill/>
+        </p:spPr>
+        <p:txBody>
+          <a:bodyPr wrap="square" anchor="t" lIns="45720" rIns="45720" tIns="27432" bIns="27432">
+            <a:spAutoFit/>
+          </a:bodyPr>
+          <a:lstStyle/>
+          <a:p>
+            <a:pPr algn="l"/>
+            <a:r>
+              <a:rPr sz="1800" b="1" i="0">
+                <a:solidFill>
+                  <a:srgbClr val="111111"/>
+                </a:solidFill>
+                <a:latin typeface="Calibri"/>
+              </a:rPr>
+              <a:t>2. Tag each task</a:t>
+            </a:r>
+          </a:p>
+        </p:txBody>
+      </p:sp>
+      <p:sp>
+        <p:nvSpPr>
+          <p:cNvPr id="11" name="TextBox 10"/>
+          <p:cNvSpPr txBox="1"/>
+          <p:nvPr/>
+        </p:nvSpPr>
+        <p:spPr>
+          <a:xfrm>
+            <a:off x="1097280" y="2688336"/>
+            <a:ext cx="10545775" cy="493776"/>
+          </a:xfrm>
+          <a:prstGeom prst="rect">
+            <a:avLst/>
+          </a:prstGeom>
+          <a:noFill/>
+        </p:spPr>
+        <p:txBody>
+          <a:bodyPr wrap="square" anchor="t" lIns="45720" rIns="45720" tIns="27432" bIns="27432">
+            <a:spAutoFit/>
+          </a:bodyPr>
+          <a:lstStyle/>
+          <a:p>
+            <a:pPr algn="l"/>
+            <a:r>
+              <a:rPr sz="1500" b="0" i="0">
+                <a:solidFill>
+                  <a:srgbClr val="111111"/>
+                </a:solidFill>
+                <a:latin typeface="Calibri"/>
+              </a:rPr>
+              <a:t>Frequency (daily, weekly, monthly); Minutes per occurrence; Judgement needed (none, some, a lot).</a:t>
+            </a:r>
+          </a:p>
+        </p:txBody>
+      </p:sp>
+      <p:sp>
+        <p:nvSpPr>
+          <p:cNvPr id="12" name="Rectangle 11"/>
+          <p:cNvSpPr/>
+          <p:nvPr/>
+        </p:nvSpPr>
+        <p:spPr>
+          <a:xfrm>
+            <a:off x="1097280" y="3182112"/>
+            <a:ext cx="10545775" cy="19050"/>
+          </a:xfrm>
+          <a:prstGeom prst="rect">
+            <a:avLst/>
+          </a:prstGeom>
+          <a:solidFill>
+            <a:srgbClr val="DDDDDD"/>
+          </a:solidFill>
+          <a:ln>
+            <a:noFill/>
+          </a:ln>
+          <a:effectLst/>
+        </p:spPr>
+        <p:style>
+          <a:lnRef idx="1">
+            <a:schemeClr val="accent1"/>
+          </a:lnRef>
+          <a:fillRef idx="3">
+            <a:schemeClr val="accent1"/>
+          </a:fillRef>
+          <a:effectRef idx="2">
+            <a:schemeClr val="accent1"/>
+          </a:effectRef>
+          <a:fontRef idx="minor">
+            <a:schemeClr val="lt1"/>
+          </a:fontRef>
+        </p:style>
+        <p:txBody>
+          <a:bodyPr rtlCol="0" anchor="ctr"/>
+          <a:lstStyle/>
+          <a:p>
+            <a:pPr algn="ctr"/>
+          </a:p>
+        </p:txBody>
+      </p:sp>
+      <p:sp>
+        <p:nvSpPr>
+          <p:cNvPr id="13" name="Oval 12"/>
+          <p:cNvSpPr/>
+          <p:nvPr/>
+        </p:nvSpPr>
+        <p:spPr>
+          <a:xfrm>
+            <a:off x="548640" y="3300984"/>
+            <a:ext cx="384048" cy="384048"/>
+          </a:xfrm>
+          <a:prstGeom prst="ellipse">
+            <a:avLst/>
+          </a:prstGeom>
+          <a:solidFill>
+            <a:srgbClr val="F7A11A"/>
+          </a:solidFill>
+          <a:ln>
+            <a:noFill/>
+          </a:ln>
+          <a:effectLst/>
+        </p:spPr>
+        <p:style>
+          <a:lnRef idx="1">
+            <a:schemeClr val="accent1"/>
+          </a:lnRef>
+          <a:fillRef idx="3">
+            <a:schemeClr val="accent1"/>
+          </a:fillRef>
+          <a:effectRef idx="2">
+            <a:schemeClr val="accent1"/>
+          </a:effectRef>
+          <a:fontRef idx="minor">
+            <a:schemeClr val="lt1"/>
+          </a:fontRef>
+        </p:style>
+        <p:txBody>
+          <a:bodyPr rtlCol="0" anchor="ctr" lIns="0" rIns="0"/>
+          <a:lstStyle/>
+          <a:p>
+            <a:pPr algn="ctr"/>
+            <a:r>
+              <a:rPr sz="1300" b="1">
+                <a:solidFill>
+                  <a:srgbClr val="FFFFFF"/>
+                </a:solidFill>
+                <a:latin typeface="Calibri"/>
+              </a:rPr>
+              <a:t>3</a:t>
+            </a:r>
+          </a:p>
+        </p:txBody>
+      </p:sp>
+      <p:sp>
+        <p:nvSpPr>
+          <p:cNvPr id="14" name="TextBox 13"/>
+          <p:cNvSpPr txBox="1"/>
+          <p:nvPr/>
+        </p:nvSpPr>
+        <p:spPr>
+          <a:xfrm>
+            <a:off x="1097280" y="3227832"/>
+            <a:ext cx="10545775" cy="457200"/>
+          </a:xfrm>
+          <a:prstGeom prst="rect">
+            <a:avLst/>
+          </a:prstGeom>
+          <a:noFill/>
+        </p:spPr>
+        <p:txBody>
+          <a:bodyPr wrap="square" anchor="t" lIns="45720" rIns="45720" tIns="27432" bIns="27432">
+            <a:spAutoFit/>
+          </a:bodyPr>
+          <a:lstStyle/>
+          <a:p>
+            <a:pPr algn="l"/>
+            <a:r>
+              <a:rPr sz="1800" b="1" i="0">
+                <a:solidFill>
+                  <a:srgbClr val="111111"/>
+                </a:solidFill>
+                <a:latin typeface="Calibri"/>
+              </a:rPr>
+              <a:t>3. Classify the design</a:t>
+            </a:r>
+          </a:p>
+        </p:txBody>
+      </p:sp>
+      <p:sp>
+        <p:nvSpPr>
+          <p:cNvPr id="15" name="TextBox 14"/>
+          <p:cNvSpPr txBox="1"/>
+          <p:nvPr/>
+        </p:nvSpPr>
+        <p:spPr>
+          <a:xfrm>
+            <a:off x="1097280" y="3639312"/>
+            <a:ext cx="10545775" cy="493776"/>
+          </a:xfrm>
+          <a:prstGeom prst="rect">
+            <a:avLst/>
+          </a:prstGeom>
+          <a:noFill/>
+        </p:spPr>
+        <p:txBody>
+          <a:bodyPr wrap="square" anchor="t" lIns="45720" rIns="45720" tIns="27432" bIns="27432">
+            <a:spAutoFit/>
+          </a:bodyPr>
+          <a:lstStyle/>
+          <a:p>
+            <a:pPr algn="l"/>
+            <a:r>
+              <a:rPr sz="1500" b="0" i="0">
+                <a:solidFill>
+                  <a:srgbClr val="111111"/>
+                </a:solidFill>
+                <a:latin typeface="Calibri"/>
+              </a:rPr>
+              <a:t>Automation, Workflow with AI step, Agent, or Keep human. Use the five-tasks table as a guide.</a:t>
+            </a:r>
+          </a:p>
+        </p:txBody>
+      </p:sp>
+      <p:sp>
+        <p:nvSpPr>
+          <p:cNvPr id="16" name="Rectangle 15"/>
+          <p:cNvSpPr/>
+          <p:nvPr/>
+        </p:nvSpPr>
+        <p:spPr>
+          <a:xfrm>
+            <a:off x="1097280" y="4133088"/>
+            <a:ext cx="10545775" cy="19050"/>
+          </a:xfrm>
+          <a:prstGeom prst="rect">
+            <a:avLst/>
+          </a:prstGeom>
+          <a:solidFill>
+            <a:srgbClr val="DDDDDD"/>
+          </a:solidFill>
+          <a:ln>
+            <a:noFill/>
+          </a:ln>
+          <a:effectLst/>
+        </p:spPr>
+        <p:style>
+          <a:lnRef idx="1">
+            <a:schemeClr val="accent1"/>
+          </a:lnRef>
+          <a:fillRef idx="3">
+            <a:schemeClr val="accent1"/>
+          </a:fillRef>
+          <a:effectRef idx="2">
+            <a:schemeClr val="accent1"/>
+          </a:effectRef>
+          <a:fontRef idx="minor">
+            <a:schemeClr val="lt1"/>
+          </a:fontRef>
+        </p:style>
+        <p:txBody>
+          <a:bodyPr rtlCol="0" anchor="ctr"/>
+          <a:lstStyle/>
+          <a:p>
+            <a:pPr algn="ctr"/>
+          </a:p>
+        </p:txBody>
+      </p:sp>
+      <p:sp>
+        <p:nvSpPr>
+          <p:cNvPr id="17" name="Oval 16"/>
+          <p:cNvSpPr/>
+          <p:nvPr/>
+        </p:nvSpPr>
+        <p:spPr>
+          <a:xfrm>
+            <a:off x="548640" y="4251960"/>
+            <a:ext cx="384048" cy="384048"/>
+          </a:xfrm>
+          <a:prstGeom prst="ellipse">
+            <a:avLst/>
+          </a:prstGeom>
+          <a:solidFill>
+            <a:srgbClr val="F7A11A"/>
+          </a:solidFill>
+          <a:ln>
+            <a:noFill/>
+          </a:ln>
+          <a:effectLst/>
+        </p:spPr>
+        <p:style>
+          <a:lnRef idx="1">
+            <a:schemeClr val="accent1"/>
+          </a:lnRef>
+          <a:fillRef idx="3">
+            <a:schemeClr val="accent1"/>
+          </a:fillRef>
+          <a:effectRef idx="2">
+            <a:schemeClr val="accent1"/>
+          </a:effectRef>
+          <a:fontRef idx="minor">
+            <a:schemeClr val="lt1"/>
+          </a:fontRef>
+        </p:style>
+        <p:txBody>
+          <a:bodyPr rtlCol="0" anchor="ctr" lIns="0" rIns="0"/>
+          <a:lstStyle/>
+          <a:p>
+            <a:pPr algn="ctr"/>
+            <a:r>
+              <a:rPr sz="1300" b="1">
+                <a:solidFill>
+                  <a:srgbClr val="FFFFFF"/>
+                </a:solidFill>
+                <a:latin typeface="Calibri"/>
+              </a:rPr>
+              <a:t>4</a:t>
+            </a:r>
+          </a:p>
+        </p:txBody>
+      </p:sp>
+      <p:sp>
+        <p:nvSpPr>
+          <p:cNvPr id="18" name="TextBox 17"/>
+          <p:cNvSpPr txBox="1"/>
+          <p:nvPr/>
+        </p:nvSpPr>
+        <p:spPr>
+          <a:xfrm>
+            <a:off x="1097280" y="4178808"/>
+            <a:ext cx="10545775" cy="457200"/>
+          </a:xfrm>
+          <a:prstGeom prst="rect">
+            <a:avLst/>
+          </a:prstGeom>
+          <a:noFill/>
+        </p:spPr>
+        <p:txBody>
+          <a:bodyPr wrap="square" anchor="t" lIns="45720" rIns="45720" tIns="27432" bIns="27432">
+            <a:spAutoFit/>
+          </a:bodyPr>
+          <a:lstStyle/>
+          <a:p>
+            <a:pPr algn="l"/>
+            <a:r>
+              <a:rPr sz="1800" b="1" i="0">
+                <a:solidFill>
+                  <a:srgbClr val="111111"/>
+                </a:solidFill>
+                <a:latin typeface="Calibri"/>
+              </a:rPr>
+              <a:t>4. Ask your assistant to challenge you</a:t>
+            </a:r>
+          </a:p>
+        </p:txBody>
+      </p:sp>
+      <p:sp>
+        <p:nvSpPr>
+          <p:cNvPr id="19" name="TextBox 18"/>
+          <p:cNvSpPr txBox="1"/>
+          <p:nvPr/>
+        </p:nvSpPr>
+        <p:spPr>
+          <a:xfrm>
+            <a:off x="1097280" y="4590288"/>
+            <a:ext cx="10545775" cy="493776"/>
+          </a:xfrm>
+          <a:prstGeom prst="rect">
+            <a:avLst/>
+          </a:prstGeom>
+          <a:noFill/>
+        </p:spPr>
+        <p:txBody>
+          <a:bodyPr wrap="square" anchor="t" lIns="45720" rIns="45720" tIns="27432" bIns="27432">
+            <a:spAutoFit/>
+          </a:bodyPr>
+          <a:lstStyle/>
+          <a:p>
+            <a:pPr algn="l"/>
+            <a:r>
+              <a:rPr sz="1500" b="0" i="0">
+                <a:solidFill>
+                  <a:srgbClr val="111111"/>
+                </a:solidFill>
+                <a:latin typeface="Calibri"/>
+              </a:rPr>
+              <a:t>Paste the table with the prompt on the next slide. Note where it disagrees.</a:t>
+            </a:r>
+          </a:p>
+        </p:txBody>
+      </p:sp>
+      <p:sp>
+        <p:nvSpPr>
+          <p:cNvPr id="20" name="Rectangle 19"/>
+          <p:cNvSpPr/>
+          <p:nvPr/>
+        </p:nvSpPr>
+        <p:spPr>
+          <a:xfrm>
+            <a:off x="1097280" y="5084064"/>
+            <a:ext cx="10545775" cy="19050"/>
+          </a:xfrm>
+          <a:prstGeom prst="rect">
+            <a:avLst/>
+          </a:prstGeom>
+          <a:solidFill>
+            <a:srgbClr val="DDDDDD"/>
+          </a:solidFill>
+          <a:ln>
+            <a:noFill/>
+          </a:ln>
+          <a:effectLst/>
+        </p:spPr>
+        <p:style>
+          <a:lnRef idx="1">
+            <a:schemeClr val="accent1"/>
+          </a:lnRef>
+          <a:fillRef idx="3">
+            <a:schemeClr val="accent1"/>
+          </a:fillRef>
+          <a:effectRef idx="2">
+            <a:schemeClr val="accent1"/>
+          </a:effectRef>
+          <a:fontRef idx="minor">
+            <a:schemeClr val="lt1"/>
+          </a:fontRef>
+        </p:style>
+        <p:txBody>
+          <a:bodyPr rtlCol="0" anchor="ctr"/>
+          <a:lstStyle/>
+          <a:p>
+            <a:pPr algn="ctr"/>
+          </a:p>
+        </p:txBody>
+      </p:sp>
+      <p:sp>
+        <p:nvSpPr>
+          <p:cNvPr id="21" name="Oval 20"/>
+          <p:cNvSpPr/>
+          <p:nvPr/>
+        </p:nvSpPr>
+        <p:spPr>
+          <a:xfrm>
+            <a:off x="548640" y="5202936"/>
+            <a:ext cx="384048" cy="384048"/>
+          </a:xfrm>
+          <a:prstGeom prst="ellipse">
+            <a:avLst/>
+          </a:prstGeom>
+          <a:solidFill>
+            <a:srgbClr val="F7A11A"/>
+          </a:solidFill>
+          <a:ln>
+            <a:noFill/>
+          </a:ln>
+          <a:effectLst/>
+        </p:spPr>
+        <p:style>
+          <a:lnRef idx="1">
+            <a:schemeClr val="accent1"/>
+          </a:lnRef>
+          <a:fillRef idx="3">
+            <a:schemeClr val="accent1"/>
+          </a:fillRef>
+          <a:effectRef idx="2">
+            <a:schemeClr val="accent1"/>
+          </a:effectRef>
+          <a:fontRef idx="minor">
+            <a:schemeClr val="lt1"/>
+          </a:fontRef>
+        </p:style>
+        <p:txBody>
+          <a:bodyPr rtlCol="0" anchor="ctr" lIns="0" rIns="0"/>
+          <a:lstStyle/>
+          <a:p>
+            <a:pPr algn="ctr"/>
+            <a:r>
+              <a:rPr sz="1300" b="1">
+                <a:solidFill>
+                  <a:srgbClr val="FFFFFF"/>
+                </a:solidFill>
+                <a:latin typeface="Calibri"/>
+              </a:rPr>
+              <a:t>5</a:t>
+            </a:r>
+          </a:p>
+        </p:txBody>
+      </p:sp>
+      <p:sp>
+        <p:nvSpPr>
+          <p:cNvPr id="22" name="TextBox 21"/>
+          <p:cNvSpPr txBox="1"/>
+          <p:nvPr/>
+        </p:nvSpPr>
+        <p:spPr>
+          <a:xfrm>
+            <a:off x="1097280" y="5129784"/>
+            <a:ext cx="10545775" cy="457200"/>
+          </a:xfrm>
+          <a:prstGeom prst="rect">
+            <a:avLst/>
+          </a:prstGeom>
+          <a:noFill/>
+        </p:spPr>
+        <p:txBody>
+          <a:bodyPr wrap="square" anchor="t" lIns="45720" rIns="45720" tIns="27432" bIns="27432">
+            <a:spAutoFit/>
+          </a:bodyPr>
+          <a:lstStyle/>
+          <a:p>
+            <a:pPr algn="l"/>
+            <a:r>
+              <a:rPr sz="1800" b="1" i="0">
+                <a:solidFill>
+                  <a:srgbClr val="111111"/>
+                </a:solidFill>
+                <a:latin typeface="Calibri"/>
+              </a:rPr>
+              <a:t>5. Pick your course task</a:t>
+            </a:r>
+          </a:p>
+        </p:txBody>
+      </p:sp>
+      <p:sp>
+        <p:nvSpPr>
+          <p:cNvPr id="23" name="TextBox 22"/>
+          <p:cNvSpPr txBox="1"/>
+          <p:nvPr/>
+        </p:nvSpPr>
+        <p:spPr>
+          <a:xfrm>
+            <a:off x="1097280" y="5541264"/>
+            <a:ext cx="10545775" cy="493776"/>
+          </a:xfrm>
+          <a:prstGeom prst="rect">
+            <a:avLst/>
+          </a:prstGeom>
+          <a:noFill/>
+        </p:spPr>
+        <p:txBody>
+          <a:bodyPr wrap="square" anchor="t" lIns="45720" rIns="45720" tIns="27432" bIns="27432">
+            <a:spAutoFit/>
+          </a:bodyPr>
+          <a:lstStyle/>
+          <a:p>
+            <a:pPr algn="l"/>
+            <a:r>
+              <a:rPr sz="1500" b="0" i="0">
+                <a:solidFill>
+                  <a:srgbClr val="111111"/>
+                </a:solidFill>
+                <a:latin typeface="Calibri"/>
+              </a:rPr>
+              <a:t>One 'Workflow with AI step' task taking 30+ minutes a week. You will map, build and control it over the course.</a:t>
+            </a:r>
+          </a:p>
+        </p:txBody>
+      </p:sp>
+      <p:sp>
+        <p:nvSpPr>
+          <p:cNvPr id="24" name="Rectangle 23"/>
+          <p:cNvSpPr/>
+          <p:nvPr/>
+        </p:nvSpPr>
+        <p:spPr>
+          <a:xfrm>
+            <a:off x="548640" y="6309360"/>
+            <a:ext cx="11094415" cy="19050"/>
+          </a:xfrm>
+          <a:prstGeom prst="rect">
+            <a:avLst/>
+          </a:prstGeom>
+          <a:solidFill>
+            <a:srgbClr val="DDDDDD"/>
+          </a:solidFill>
+          <a:ln>
+            <a:noFill/>
+          </a:ln>
+          <a:effectLst/>
+        </p:spPr>
+        <p:style>
+          <a:lnRef idx="1">
+            <a:schemeClr val="accent1"/>
+          </a:lnRef>
+          <a:fillRef idx="3">
+            <a:schemeClr val="accent1"/>
+          </a:fillRef>
+          <a:effectRef idx="2">
+            <a:schemeClr val="accent1"/>
+          </a:effectRef>
+          <a:fontRef idx="minor">
+            <a:schemeClr val="lt1"/>
+          </a:fontRef>
+        </p:style>
+        <p:txBody>
+          <a:bodyPr rtlCol="0" anchor="ctr"/>
+          <a:lstStyle/>
+          <a:p>
+            <a:pPr algn="ctr"/>
+          </a:p>
+        </p:txBody>
+      </p:sp>
+      <p:sp>
+        <p:nvSpPr>
+          <p:cNvPr id="25" name="TextBox 24"/>
           <p:cNvSpPr txBox="1"/>
           <p:nvPr/>
         </p:nvSpPr>
@@ -29939,7 +30180,7 @@
       </p:sp>
       <p:sp>
         <p:nvSpPr>
-          <p:cNvPr id="9" name="TextBox 8"/>
+          <p:cNvPr id="26" name="TextBox 25"/>
           <p:cNvSpPr txBox="1"/>
           <p:nvPr/>
         </p:nvSpPr>
@@ -29998,8 +30239,8 @@
         </p:nvSpPr>
         <p:spPr>
           <a:xfrm>
-            <a:off x="548640" y="2011680"/>
-            <a:ext cx="11094415" cy="457200"/>
+            <a:off x="548640" y="365760"/>
+            <a:ext cx="11094415" cy="777240"/>
           </a:xfrm>
           <a:prstGeom prst="rect">
             <a:avLst/>
@@ -30007,20 +30248,20 @@
           <a:noFill/>
         </p:spPr>
         <p:txBody>
-          <a:bodyPr wrap="square" anchor="t" lIns="45720" rIns="45720" tIns="27432" bIns="27432">
+          <a:bodyPr wrap="square" anchor="b" lIns="45720" rIns="45720" tIns="27432" bIns="27432">
             <a:spAutoFit/>
           </a:bodyPr>
           <a:lstStyle/>
           <a:p>
             <a:pPr algn="l"/>
             <a:r>
-              <a:rPr sz="1400" b="0" i="0">
-                <a:solidFill>
-                  <a:srgbClr val="666666"/>
-                </a:solidFill>
-                <a:latin typeface="Calibri"/>
-              </a:rPr>
-              <a:t>Section · minute 110</a:t>
+              <a:rPr sz="3000" b="1" i="0">
+                <a:solidFill>
+                  <a:srgbClr val="111111"/>
+                </a:solidFill>
+                <a:latin typeface="Calibri"/>
+              </a:rPr>
+              <a:t>Step 4: the challenge prompt</a:t>
             </a:r>
           </a:p>
         </p:txBody>
@@ -30033,8 +30274,8 @@
         </p:nvSpPr>
         <p:spPr>
           <a:xfrm>
-            <a:off x="548640" y="2514600"/>
-            <a:ext cx="1463040" cy="50800"/>
+            <a:off x="548640" y="1115568"/>
+            <a:ext cx="1097280" cy="38100"/>
           </a:xfrm>
           <a:prstGeom prst="rect">
             <a:avLst/>
@@ -30071,14 +30312,104 @@
       </p:sp>
       <p:sp>
         <p:nvSpPr>
-          <p:cNvPr id="4" name="TextBox 3"/>
+          <p:cNvPr id="4" name="Rectangle 3"/>
+          <p:cNvSpPr/>
+          <p:nvPr/>
+        </p:nvSpPr>
+        <p:spPr>
+          <a:xfrm>
+            <a:off x="1645920" y="1115568"/>
+            <a:ext cx="9997135" cy="19050"/>
+          </a:xfrm>
+          <a:prstGeom prst="rect">
+            <a:avLst/>
+          </a:prstGeom>
+          <a:solidFill>
+            <a:srgbClr val="DDDDDD"/>
+          </a:solidFill>
+          <a:ln>
+            <a:noFill/>
+          </a:ln>
+          <a:effectLst/>
+        </p:spPr>
+        <p:style>
+          <a:lnRef idx="1">
+            <a:schemeClr val="accent1"/>
+          </a:lnRef>
+          <a:fillRef idx="3">
+            <a:schemeClr val="accent1"/>
+          </a:fillRef>
+          <a:effectRef idx="2">
+            <a:schemeClr val="accent1"/>
+          </a:effectRef>
+          <a:fontRef idx="minor">
+            <a:schemeClr val="lt1"/>
+          </a:fontRef>
+        </p:style>
+        <p:txBody>
+          <a:bodyPr rtlCol="0" anchor="ctr"/>
+          <a:lstStyle/>
+          <a:p>
+            <a:pPr algn="ctr"/>
+          </a:p>
+        </p:txBody>
+      </p:sp>
+      <p:sp>
+        <p:nvSpPr>
+          <p:cNvPr id="5" name="Rectangle 4"/>
+          <p:cNvSpPr/>
+          <p:nvPr/>
+        </p:nvSpPr>
+        <p:spPr>
+          <a:xfrm>
+            <a:off x="548640" y="1371600"/>
+            <a:ext cx="11094415" cy="4663440"/>
+          </a:xfrm>
+          <a:prstGeom prst="rect">
+            <a:avLst/>
+          </a:prstGeom>
+          <a:solidFill>
+            <a:srgbClr val="F2F2F2"/>
+          </a:solidFill>
+          <a:ln>
+            <a:solidFill>
+              <a:srgbClr val="DDDDDD"/>
+            </a:solidFill>
+          </a:ln>
+          <a:effectLst/>
+        </p:spPr>
+        <p:style>
+          <a:lnRef idx="1">
+            <a:schemeClr val="accent1"/>
+          </a:lnRef>
+          <a:fillRef idx="3">
+            <a:schemeClr val="accent1"/>
+          </a:fillRef>
+          <a:effectRef idx="2">
+            <a:schemeClr val="accent1"/>
+          </a:effectRef>
+          <a:fontRef idx="minor">
+            <a:schemeClr val="lt1"/>
+          </a:fontRef>
+        </p:style>
+        <p:txBody>
+          <a:bodyPr rtlCol="0" anchor="ctr"/>
+          <a:lstStyle/>
+          <a:p>
+            <a:pPr algn="ctr"/>
+          </a:p>
+        </p:txBody>
+      </p:sp>
+      <p:sp>
+        <p:nvSpPr>
+          <p:cNvPr id="6" name="TextBox 5"/>
           <p:cNvSpPr txBox="1"/>
           <p:nvPr/>
         </p:nvSpPr>
         <p:spPr>
           <a:xfrm>
-            <a:off x="548640" y="2651760"/>
-            <a:ext cx="11094415" cy="1371600"/>
+            <a:off x="822960" y="1554480"/>
+            <a:ext cx="10545775" cy="4297680"/>
           </a:xfrm>
           <a:prstGeom prst="rect">
             <a:avLst/>
@@ -30093,83 +30424,61 @@
           <a:p>
             <a:pPr algn="l"/>
             <a:r>
-              <a:rPr sz="3800" b="1" i="0">
+              <a:rPr sz="1600" b="0" i="0">
                 <a:solidFill>
                   <a:srgbClr val="111111"/>
                 </a:solidFill>
-                <a:latin typeface="Calibri"/>
-              </a:rPr>
-              <a:t>Kahoot: knowledge check</a:t>
-            </a:r>
-          </a:p>
-        </p:txBody>
-      </p:sp>
-      <p:sp>
-        <p:nvSpPr>
-          <p:cNvPr id="5" name="TextBox 4"/>
-          <p:cNvSpPr txBox="1"/>
-          <p:nvPr/>
-        </p:nvSpPr>
-        <p:spPr>
-          <a:xfrm>
-            <a:off x="548640" y="4023360"/>
-            <a:ext cx="11094415" cy="822960"/>
-          </a:xfrm>
-          <a:prstGeom prst="rect">
-            <a:avLst/>
-          </a:prstGeom>
-          <a:noFill/>
-        </p:spPr>
-        <p:txBody>
-          <a:bodyPr wrap="square" anchor="t" lIns="45720" rIns="45720" tIns="27432" bIns="27432">
-            <a:spAutoFit/>
-          </a:bodyPr>
-          <a:lstStyle/>
+                <a:latin typeface="Courier New"/>
+              </a:rPr>
+              <a:t>You are an operations consultant. Here is a table of my recurring tasks with my proposed design for each</a:t>
+            </a:r>
+          </a:p>
           <a:p>
             <a:pPr algn="l"/>
             <a:r>
-              <a:rPr sz="2000" b="0" i="0">
-                <a:solidFill>
-                  <a:srgbClr val="666666"/>
-                </a:solidFill>
-                <a:latin typeface="Calibri"/>
-              </a:rPr>
-              <a:t>30 questions, 20 seconds each. Phones out.</a:t>
-            </a:r>
-          </a:p>
-        </p:txBody>
-      </p:sp>
-      <p:sp>
-        <p:nvSpPr>
-          <p:cNvPr id="6" name="TextBox 5"/>
-          <p:cNvSpPr txBox="1"/>
-          <p:nvPr/>
-        </p:nvSpPr>
-        <p:spPr>
-          <a:xfrm>
-            <a:off x="548640" y="4846320"/>
-            <a:ext cx="11094415" cy="457200"/>
-          </a:xfrm>
-          <a:prstGeom prst="rect">
-            <a:avLst/>
-          </a:prstGeom>
-          <a:noFill/>
-        </p:spPr>
-        <p:txBody>
-          <a:bodyPr wrap="square" anchor="t" lIns="45720" rIns="45720" tIns="27432" bIns="27432">
-            <a:spAutoFit/>
-          </a:bodyPr>
-          <a:lstStyle/>
+              <a:rPr sz="1600" b="0" i="0">
+                <a:solidFill>
+                  <a:srgbClr val="111111"/>
+                </a:solidFill>
+                <a:latin typeface="Courier New"/>
+              </a:rPr>
+              <a:t>(Automation, Workflow with AI step, Agent, Keep human). For each row, say whether you agree, and if not, why.</a:t>
+            </a:r>
+          </a:p>
           <a:p>
             <a:pPr algn="l"/>
             <a:r>
-              <a:rPr sz="1400" b="0" i="0">
-                <a:solidFill>
-                  <a:srgbClr val="666666"/>
-                </a:solidFill>
-                <a:latin typeface="Calibri"/>
-              </a:rPr>
-              <a:t>About 10 minutes</a:t>
+              <a:rPr sz="1600" b="0" i="0">
+                <a:solidFill>
+                  <a:srgbClr val="111111"/>
+                </a:solidFill>
+                <a:latin typeface="Courier New"/>
+              </a:rPr>
+              <a:t>Then rank the top three tasks by time saved per week. Be brief.</a:t>
+            </a:r>
+          </a:p>
+          <a:p>
+            <a:pPr algn="l"/>
+            <a:r>
+              <a:rPr sz="1600" b="0" i="0">
+                <a:solidFill>
+                  <a:srgbClr val="111111"/>
+                </a:solidFill>
+                <a:latin typeface="Courier New"/>
+              </a:rPr>
+              <a:t/>
+            </a:r>
+          </a:p>
+          <a:p>
+            <a:pPr algn="l"/>
+            <a:r>
+              <a:rPr sz="1600" b="0" i="0">
+                <a:solidFill>
+                  <a:srgbClr val="111111"/>
+                </a:solidFill>
+                <a:latin typeface="Courier New"/>
+              </a:rPr>
+              <a:t>[paste your table here]</a:t>
             </a:r>
           </a:p>
         </p:txBody>
@@ -30336,7 +30645,7 @@
                 </a:solidFill>
                 <a:latin typeface="Calibri"/>
               </a:rPr>
-              <a:t>Join the Kahoot</a:t>
+              <a:t>Deliverable</a:t>
             </a:r>
           </a:p>
         </p:txBody>
@@ -30431,49 +30740,14 @@
       </p:sp>
       <p:sp>
         <p:nvSpPr>
-          <p:cNvPr id="5" name="TextBox 4"/>
-          <p:cNvSpPr txBox="1"/>
-          <p:nvPr/>
-        </p:nvSpPr>
-        <p:spPr>
-          <a:xfrm>
-            <a:off x="548640" y="1325880"/>
-            <a:ext cx="5318607" cy="457200"/>
-          </a:xfrm>
-          <a:prstGeom prst="rect">
-            <a:avLst/>
-          </a:prstGeom>
-          <a:noFill/>
-        </p:spPr>
-        <p:txBody>
-          <a:bodyPr wrap="square" anchor="t" lIns="45720" rIns="45720" tIns="27432" bIns="27432">
-            <a:spAutoFit/>
-          </a:bodyPr>
-          <a:lstStyle/>
-          <a:p>
-            <a:pPr algn="l"/>
-            <a:r>
-              <a:rPr sz="2000" b="1" i="0">
-                <a:solidFill>
-                  <a:srgbClr val="111111"/>
-                </a:solidFill>
-                <a:latin typeface="Calibri"/>
-              </a:rPr>
-              <a:t>How to join</a:t>
-            </a:r>
-          </a:p>
-        </p:txBody>
-      </p:sp>
-      <p:sp>
-        <p:nvSpPr>
-          <p:cNvPr id="6" name="Rectangle 5"/>
+          <p:cNvPr id="5" name="Rectangle 4"/>
           <p:cNvSpPr/>
           <p:nvPr/>
         </p:nvSpPr>
         <p:spPr>
           <a:xfrm>
-            <a:off x="548640" y="1801368"/>
-            <a:ext cx="5318607" cy="25400"/>
+            <a:off x="548640" y="1783080"/>
+            <a:ext cx="76200" cy="2926080"/>
           </a:xfrm>
           <a:prstGeom prst="rect">
             <a:avLst/>
@@ -30510,14 +30784,14 @@
       </p:sp>
       <p:sp>
         <p:nvSpPr>
-          <p:cNvPr id="7" name="TextBox 6"/>
+          <p:cNvPr id="6" name="TextBox 5"/>
           <p:cNvSpPr txBox="1"/>
           <p:nvPr/>
         </p:nvSpPr>
         <p:spPr>
           <a:xfrm>
-            <a:off x="548640" y="1920240"/>
-            <a:ext cx="5318607" cy="4297680"/>
+            <a:off x="914400" y="1783080"/>
+            <a:ext cx="10728655" cy="2926080"/>
           </a:xfrm>
           <a:prstGeom prst="rect">
             <a:avLst/>
@@ -30525,245 +30799,27 @@
           <a:noFill/>
         </p:spPr>
         <p:txBody>
-          <a:bodyPr wrap="square" lIns="45720" rIns="45720">
+          <a:bodyPr wrap="square" anchor="ctr" lIns="45720" rIns="45720" tIns="27432" bIns="27432">
             <a:spAutoFit/>
           </a:bodyPr>
           <a:lstStyle/>
           <a:p>
-            <a:pPr>
-              <a:spcAft>
-                <a:spcPts val="1000"/>
-              </a:spcAft>
-            </a:pPr>
-            <a:r>
-              <a:rPr sz="1800">
+            <a:pPr algn="l"/>
+            <a:r>
+              <a:rPr sz="2800" b="0" i="0">
                 <a:solidFill>
                   <a:srgbClr val="111111"/>
                 </a:solidFill>
                 <a:latin typeface="Calibri"/>
               </a:rPr>
-              <a:t>•  Open kahoot.it on your phone, or the Kahoot app</a:t>
-            </a:r>
-          </a:p>
-          <a:p>
-            <a:pPr>
-              <a:spcAft>
-                <a:spcPts val="1000"/>
-              </a:spcAft>
-            </a:pPr>
-            <a:r>
-              <a:rPr sz="1800">
-                <a:solidFill>
-                  <a:srgbClr val="111111"/>
-                </a:solidFill>
-                <a:latin typeface="Calibri"/>
-              </a:rPr>
-              <a:t>•  Enter the game PIN shown on the screen</a:t>
-            </a:r>
-          </a:p>
-          <a:p>
-            <a:pPr>
-              <a:spcAft>
-                <a:spcPts val="1000"/>
-              </a:spcAft>
-            </a:pPr>
-            <a:r>
-              <a:rPr sz="1800">
-                <a:solidFill>
-                  <a:srgbClr val="111111"/>
-                </a:solidFill>
-                <a:latin typeface="Calibri"/>
-              </a:rPr>
-              <a:t>•  Nickname: your first name</a:t>
-            </a:r>
-          </a:p>
-          <a:p>
-            <a:pPr>
-              <a:spcAft>
-                <a:spcPts val="1000"/>
-              </a:spcAft>
-            </a:pPr>
-            <a:r>
-              <a:rPr sz="1800">
-                <a:solidFill>
-                  <a:srgbClr val="111111"/>
-                </a:solidFill>
-                <a:latin typeface="Calibri"/>
-              </a:rPr>
-              <a:t>•  20 seconds per question; answer on your phone</a:t>
-            </a:r>
-          </a:p>
-        </p:txBody>
-      </p:sp>
-      <p:sp>
-        <p:nvSpPr>
-          <p:cNvPr id="8" name="TextBox 7"/>
-          <p:cNvSpPr txBox="1"/>
-          <p:nvPr/>
-        </p:nvSpPr>
-        <p:spPr>
-          <a:xfrm>
-            <a:off x="6324447" y="1325880"/>
-            <a:ext cx="5318607" cy="457200"/>
-          </a:xfrm>
-          <a:prstGeom prst="rect">
-            <a:avLst/>
-          </a:prstGeom>
-          <a:noFill/>
-        </p:spPr>
-        <p:txBody>
-          <a:bodyPr wrap="square" anchor="t" lIns="45720" rIns="45720" tIns="27432" bIns="27432">
-            <a:spAutoFit/>
-          </a:bodyPr>
-          <a:lstStyle/>
-          <a:p>
-            <a:pPr algn="l"/>
-            <a:r>
-              <a:rPr sz="2000" b="1" i="0">
-                <a:solidFill>
-                  <a:srgbClr val="111111"/>
-                </a:solidFill>
-                <a:latin typeface="Calibri"/>
-              </a:rPr>
-              <a:t>Fair play notes</a:t>
-            </a:r>
-          </a:p>
-        </p:txBody>
-      </p:sp>
-      <p:sp>
-        <p:nvSpPr>
-          <p:cNvPr id="9" name="Rectangle 8"/>
-          <p:cNvSpPr/>
-          <p:nvPr/>
-        </p:nvSpPr>
-        <p:spPr>
-          <a:xfrm>
-            <a:off x="6324447" y="1801368"/>
-            <a:ext cx="5318607" cy="25400"/>
-          </a:xfrm>
-          <a:prstGeom prst="rect">
-            <a:avLst/>
-          </a:prstGeom>
-          <a:solidFill>
-            <a:srgbClr val="666666"/>
-          </a:solidFill>
-          <a:ln>
-            <a:noFill/>
-          </a:ln>
-          <a:effectLst/>
-        </p:spPr>
-        <p:style>
-          <a:lnRef idx="1">
-            <a:schemeClr val="accent1"/>
-          </a:lnRef>
-          <a:fillRef idx="3">
-            <a:schemeClr val="accent1"/>
-          </a:fillRef>
-          <a:effectRef idx="2">
-            <a:schemeClr val="accent1"/>
-          </a:effectRef>
-          <a:fontRef idx="minor">
-            <a:schemeClr val="lt1"/>
-          </a:fontRef>
-        </p:style>
-        <p:txBody>
-          <a:bodyPr rtlCol="0" anchor="ctr"/>
-          <a:lstStyle/>
-          <a:p>
-            <a:pPr algn="ctr"/>
-          </a:p>
-        </p:txBody>
-      </p:sp>
-      <p:sp>
-        <p:nvSpPr>
-          <p:cNvPr id="10" name="TextBox 9"/>
-          <p:cNvSpPr txBox="1"/>
-          <p:nvPr/>
-        </p:nvSpPr>
-        <p:spPr>
-          <a:xfrm>
-            <a:off x="6324447" y="1920240"/>
-            <a:ext cx="5318607" cy="4297680"/>
-          </a:xfrm>
-          <a:prstGeom prst="rect">
-            <a:avLst/>
-          </a:prstGeom>
-          <a:noFill/>
-        </p:spPr>
-        <p:txBody>
-          <a:bodyPr wrap="square" lIns="45720" rIns="45720">
-            <a:spAutoFit/>
-          </a:bodyPr>
-          <a:lstStyle/>
-          <a:p>
-            <a:pPr>
-              <a:spcAft>
-                <a:spcPts val="1000"/>
-              </a:spcAft>
-            </a:pPr>
-            <a:r>
-              <a:rPr sz="1800">
-                <a:solidFill>
-                  <a:srgbClr val="111111"/>
-                </a:solidFill>
-                <a:latin typeface="Calibri"/>
-              </a:rPr>
-              <a:t>•  All four answers are about the same length. The long one is not a hint.</a:t>
-            </a:r>
-          </a:p>
-          <a:p>
-            <a:pPr>
-              <a:spcAft>
-                <a:spcPts val="1000"/>
-              </a:spcAft>
-            </a:pPr>
-            <a:r>
-              <a:rPr sz="1800">
-                <a:solidFill>
-                  <a:srgbClr val="111111"/>
-                </a:solidFill>
-                <a:latin typeface="Calibri"/>
-              </a:rPr>
-              <a:t>•  Correct answers are spread evenly over the four colours.</a:t>
-            </a:r>
-          </a:p>
-          <a:p>
-            <a:pPr>
-              <a:spcAft>
-                <a:spcPts val="1000"/>
-              </a:spcAft>
-            </a:pPr>
-            <a:r>
-              <a:rPr sz="1800">
-                <a:solidFill>
-                  <a:srgbClr val="111111"/>
-                </a:solidFill>
-                <a:latin typeface="Calibri"/>
-              </a:rPr>
-              <a:t>•  We run as many as time allows in the room</a:t>
-            </a:r>
-          </a:p>
-          <a:p>
-            <a:pPr>
-              <a:spcAft>
-                <a:spcPts val="1000"/>
-              </a:spcAft>
-            </a:pPr>
-            <a:r>
-              <a:rPr sz="1800">
-                <a:solidFill>
-                  <a:srgbClr val="111111"/>
-                </a:solidFill>
-                <a:latin typeface="Calibri"/>
-              </a:rPr>
-              <a:t>•  The rest arrive as a Kahoot challenge link for homework</a:t>
-            </a:r>
-          </a:p>
-        </p:txBody>
-      </p:sp>
-      <p:sp>
-        <p:nvSpPr>
-          <p:cNvPr id="11" name="Rectangle 10"/>
+              <a:t>A one-page task inventory (ten rows, four columns) with your chosen course task highlighted, saved as M1-task-inventory in your course folder. Bring it to the next session.</a:t>
+            </a:r>
+          </a:p>
+        </p:txBody>
+      </p:sp>
+      <p:sp>
+        <p:nvSpPr>
+          <p:cNvPr id="7" name="Rectangle 6"/>
           <p:cNvSpPr/>
           <p:nvPr/>
         </p:nvSpPr>
@@ -30807,7 +30863,7 @@
       </p:sp>
       <p:sp>
         <p:nvSpPr>
-          <p:cNvPr id="12" name="TextBox 11"/>
+          <p:cNvPr id="8" name="TextBox 7"/>
           <p:cNvSpPr txBox="1"/>
           <p:nvPr/>
         </p:nvSpPr>
@@ -30842,7 +30898,7 @@
       </p:sp>
       <p:sp>
         <p:nvSpPr>
-          <p:cNvPr id="13" name="TextBox 12"/>
+          <p:cNvPr id="9" name="TextBox 8"/>
           <p:cNvSpPr txBox="1"/>
           <p:nvPr/>
         </p:nvSpPr>

</xml_diff>

<commit_message>
Kahoot logo on opening slides and Kahoot section slide
</commit_message>
<xml_diff>
--- a/instructor/ai-administrator/out/day1/Day1_S1_Foundations.pptx
+++ b/instructor/ai-administrator/out/day1/Day1_S1_Foundations.pptx
@@ -12019,9 +12019,33 @@
           </a:p>
         </p:txBody>
       </p:sp>
-      <p:sp>
-        <p:nvSpPr>
-          <p:cNvPr id="5" name="TextBox 4"/>
+      <p:pic>
+        <p:nvPicPr>
+          <p:cNvPr id="5" name="Picture 4" descr="kahoot_logo.png"/>
+          <p:cNvPicPr>
+            <a:picLocks noChangeAspect="1"/>
+          </p:cNvPicPr>
+          <p:nvPr/>
+        </p:nvPicPr>
+        <p:blipFill>
+          <a:blip r:embed="rId2"/>
+          <a:stretch>
+            <a:fillRect/>
+          </a:stretch>
+        </p:blipFill>
+        <p:spPr>
+          <a:xfrm>
+            <a:off x="9315522" y="274320"/>
+            <a:ext cx="2277626" cy="777240"/>
+          </a:xfrm>
+          <a:prstGeom prst="rect">
+            <a:avLst/>
+          </a:prstGeom>
+        </p:spPr>
+      </p:pic>
+      <p:sp>
+        <p:nvSpPr>
+          <p:cNvPr id="6" name="TextBox 5"/>
           <p:cNvSpPr txBox="1"/>
           <p:nvPr/>
         </p:nvSpPr>
@@ -12156,7 +12180,7 @@
       </p:sp>
       <p:sp>
         <p:nvSpPr>
-          <p:cNvPr id="6" name="Rectangle 5"/>
+          <p:cNvPr id="7" name="Rectangle 6"/>
           <p:cNvSpPr/>
           <p:nvPr/>
         </p:nvSpPr>
@@ -12200,7 +12224,7 @@
       </p:sp>
       <p:sp>
         <p:nvSpPr>
-          <p:cNvPr id="7" name="TextBox 6"/>
+          <p:cNvPr id="8" name="TextBox 7"/>
           <p:cNvSpPr txBox="1"/>
           <p:nvPr/>
         </p:nvSpPr>
@@ -12235,7 +12259,7 @@
       </p:sp>
       <p:sp>
         <p:nvSpPr>
-          <p:cNvPr id="8" name="TextBox 7"/>
+          <p:cNvPr id="9" name="TextBox 8"/>
           <p:cNvSpPr txBox="1"/>
           <p:nvPr/>
         </p:nvSpPr>
@@ -16072,9 +16096,33 @@
           </a:p>
         </p:txBody>
       </p:sp>
-      <p:sp>
-        <p:nvSpPr>
-          <p:cNvPr id="5" name="TextBox 4"/>
+      <p:pic>
+        <p:nvPicPr>
+          <p:cNvPr id="5" name="Picture 4" descr="kahoot_logo.png"/>
+          <p:cNvPicPr>
+            <a:picLocks noChangeAspect="1"/>
+          </p:cNvPicPr>
+          <p:nvPr/>
+        </p:nvPicPr>
+        <p:blipFill>
+          <a:blip r:embed="rId2"/>
+          <a:stretch>
+            <a:fillRect/>
+          </a:stretch>
+        </p:blipFill>
+        <p:spPr>
+          <a:xfrm>
+            <a:off x="9315522" y="274320"/>
+            <a:ext cx="2277626" cy="777240"/>
+          </a:xfrm>
+          <a:prstGeom prst="rect">
+            <a:avLst/>
+          </a:prstGeom>
+        </p:spPr>
+      </p:pic>
+      <p:sp>
+        <p:nvSpPr>
+          <p:cNvPr id="6" name="TextBox 5"/>
           <p:cNvSpPr txBox="1"/>
           <p:nvPr/>
         </p:nvSpPr>
@@ -16193,7 +16241,7 @@
       </p:sp>
       <p:sp>
         <p:nvSpPr>
-          <p:cNvPr id="6" name="Rectangle 5"/>
+          <p:cNvPr id="7" name="Rectangle 6"/>
           <p:cNvSpPr/>
           <p:nvPr/>
         </p:nvSpPr>
@@ -16237,7 +16285,7 @@
       </p:sp>
       <p:sp>
         <p:nvSpPr>
-          <p:cNvPr id="7" name="TextBox 6"/>
+          <p:cNvPr id="8" name="TextBox 7"/>
           <p:cNvSpPr txBox="1"/>
           <p:nvPr/>
         </p:nvSpPr>
@@ -16272,7 +16320,7 @@
       </p:sp>
       <p:sp>
         <p:nvSpPr>
-          <p:cNvPr id="8" name="TextBox 7"/>
+          <p:cNvPr id="9" name="TextBox 8"/>
           <p:cNvSpPr txBox="1"/>
           <p:nvPr/>
         </p:nvSpPr>
@@ -28126,9 +28174,33 @@
           </a:p>
         </p:txBody>
       </p:sp>
-      <p:sp>
-        <p:nvSpPr>
-          <p:cNvPr id="7" name="Rectangle 6"/>
+      <p:pic>
+        <p:nvPicPr>
+          <p:cNvPr id="7" name="Picture 6" descr="kahoot_logo.png"/>
+          <p:cNvPicPr>
+            <a:picLocks noChangeAspect="1"/>
+          </p:cNvPicPr>
+          <p:nvPr/>
+        </p:nvPicPr>
+        <p:blipFill>
+          <a:blip r:embed="rId2"/>
+          <a:stretch>
+            <a:fillRect/>
+          </a:stretch>
+        </p:blipFill>
+        <p:spPr>
+          <a:xfrm>
+            <a:off x="6888175" y="2206219"/>
+            <a:ext cx="4754880" cy="1622602"/>
+          </a:xfrm>
+          <a:prstGeom prst="rect">
+            <a:avLst/>
+          </a:prstGeom>
+        </p:spPr>
+      </p:pic>
+      <p:sp>
+        <p:nvSpPr>
+          <p:cNvPr id="8" name="Rectangle 7"/>
           <p:cNvSpPr/>
           <p:nvPr/>
         </p:nvSpPr>
@@ -28172,7 +28244,7 @@
       </p:sp>
       <p:sp>
         <p:nvSpPr>
-          <p:cNvPr id="8" name="TextBox 7"/>
+          <p:cNvPr id="9" name="TextBox 8"/>
           <p:cNvSpPr txBox="1"/>
           <p:nvPr/>
         </p:nvSpPr>
@@ -28207,7 +28279,7 @@
       </p:sp>
       <p:sp>
         <p:nvSpPr>
-          <p:cNvPr id="9" name="TextBox 8"/>
+          <p:cNvPr id="10" name="TextBox 9"/>
           <p:cNvSpPr txBox="1"/>
           <p:nvPr/>
         </p:nvSpPr>

</xml_diff>